<commit_message>
Split expected profit and period into separate table columns
Co-Authored-By: Claude Opus 5.5 <noreply@anthropic.com>
Claude-Session: https://claude.ai/code/session_01UDmzKjjdYrug7NodmfaK5P
</commit_message>
<xml_diff>
--- a/PJT_summary.pptx
+++ b/PJT_summary.pptx
@@ -4153,11 +4153,12 @@
               <a:tblGrid>
                 <a:gridCol w="380000"/>
                 <a:gridCol w="520000"/>
-                <a:gridCol w="2100000"/>
-                <a:gridCol w="850000"/>
+                <a:gridCol w="2050000"/>
+                <a:gridCol w="800000"/>
                 <a:gridCol w="600000"/>
                 <a:gridCol w="900000"/>
-                <a:gridCol w="1000000"/>
+                <a:gridCol w="650000"/>
+                <a:gridCol w="450000"/>
               </a:tblGrid>
               <a:tr h="250000">
                 <a:tc>
@@ -4409,7 +4410,46 @@
                           <a:ea typeface="신세계 민부리 Bold(TTF)"/>
                           <a:cs typeface="신세계 민부리 Bold(TTF)"/>
                         </a:rPr>
-                        <a:t>예상 이익 / 기간</a:t>
+                        <a:t>예상 이익</a:t>
+                      </a:r>
+                    </a:p>
+                  </a:txBody>
+                  <a:tcPr marL="40000" marR="40000" marT="0" marB="0" anchor="ctr">
+                    <a:lnL w="0">
+                      <a:noFill/>
+                    </a:lnL>
+                    <a:lnR w="0">
+                      <a:noFill/>
+                    </a:lnR>
+                    <a:lnT w="15875">
+                      <a:solidFill>
+                        <a:srgbClr val="002060"/>
+                      </a:solidFill>
+                    </a:lnT>
+                    <a:lnB w="9525">
+                      <a:solidFill>
+                        <a:srgbClr val="D9D9D9"/>
+                      </a:solidFill>
+                    </a:lnB>
+                    <a:noFill/>
+                  </a:tcPr>
+                </a:tc>
+                <a:tc>
+                  <a:txBody>
+                    <a:bodyPr wrap="square"/>
+                    <a:lstStyle/>
+                    <a:p>
+                      <a:pPr algn="ctr"/>
+                      <a:r>
+                        <a:rPr sz="850" b="1">
+                          <a:solidFill>
+                            <a:srgbClr val="595959"/>
+                          </a:solidFill>
+                          <a:latin typeface="신세계 민부리 Bold(TTF)"/>
+                          <a:ea typeface="신세계 민부리 Bold(TTF)"/>
+                          <a:cs typeface="신세계 민부리 Bold(TTF)"/>
+                        </a:rPr>
+                        <a:t>기간</a:t>
                       </a:r>
                     </a:p>
                   </a:txBody>
@@ -4684,7 +4724,46 @@
                           <a:ea typeface="신세계 민부리 Light(TTF)"/>
                           <a:cs typeface="신세계 민부리 Light(TTF)"/>
                         </a:rPr>
-                        <a:t>760억 / 3년</a:t>
+                        <a:t>760억</a:t>
+                      </a:r>
+                    </a:p>
+                  </a:txBody>
+                  <a:tcPr marL="40000" marR="40000" marT="0" marB="0" anchor="ctr">
+                    <a:lnL w="0">
+                      <a:noFill/>
+                    </a:lnL>
+                    <a:lnR w="0">
+                      <a:noFill/>
+                    </a:lnR>
+                    <a:lnT w="6350">
+                      <a:solidFill>
+                        <a:srgbClr val="D9D9D9"/>
+                      </a:solidFill>
+                    </a:lnT>
+                    <a:lnB w="6350">
+                      <a:solidFill>
+                        <a:srgbClr val="D9D9D9"/>
+                      </a:solidFill>
+                    </a:lnB>
+                    <a:noFill/>
+                  </a:tcPr>
+                </a:tc>
+                <a:tc>
+                  <a:txBody>
+                    <a:bodyPr wrap="square"/>
+                    <a:lstStyle/>
+                    <a:p>
+                      <a:pPr algn="ctr"/>
+                      <a:r>
+                        <a:rPr sz="850" b="0">
+                          <a:solidFill>
+                            <a:srgbClr val="000000"/>
+                          </a:solidFill>
+                          <a:latin typeface="신세계 민부리 Light(TTF)"/>
+                          <a:ea typeface="신세계 민부리 Light(TTF)"/>
+                          <a:cs typeface="신세계 민부리 Light(TTF)"/>
+                        </a:rPr>
+                        <a:t>3년</a:t>
                       </a:r>
                     </a:p>
                   </a:txBody>
@@ -4959,7 +5038,46 @@
                           <a:ea typeface="신세계 민부리 Light(TTF)"/>
                           <a:cs typeface="신세계 민부리 Light(TTF)"/>
                         </a:rPr>
-                        <a:t>3,002억 / 12년</a:t>
+                        <a:t>3,002억</a:t>
+                      </a:r>
+                    </a:p>
+                  </a:txBody>
+                  <a:tcPr marL="40000" marR="40000" marT="0" marB="0" anchor="ctr">
+                    <a:lnL w="0">
+                      <a:noFill/>
+                    </a:lnL>
+                    <a:lnR w="0">
+                      <a:noFill/>
+                    </a:lnR>
+                    <a:lnT w="6350">
+                      <a:solidFill>
+                        <a:srgbClr val="D9D9D9"/>
+                      </a:solidFill>
+                    </a:lnT>
+                    <a:lnB w="6350">
+                      <a:solidFill>
+                        <a:srgbClr val="D9D9D9"/>
+                      </a:solidFill>
+                    </a:lnB>
+                    <a:noFill/>
+                  </a:tcPr>
+                </a:tc>
+                <a:tc>
+                  <a:txBody>
+                    <a:bodyPr wrap="square"/>
+                    <a:lstStyle/>
+                    <a:p>
+                      <a:pPr algn="ctr"/>
+                      <a:r>
+                        <a:rPr sz="850" b="0">
+                          <a:solidFill>
+                            <a:srgbClr val="000000"/>
+                          </a:solidFill>
+                          <a:latin typeface="신세계 민부리 Light(TTF)"/>
+                          <a:ea typeface="신세계 민부리 Light(TTF)"/>
+                          <a:cs typeface="신세계 민부리 Light(TTF)"/>
+                        </a:rPr>
+                        <a:t>12년</a:t>
                       </a:r>
                     </a:p>
                   </a:txBody>
@@ -5234,7 +5352,46 @@
                           <a:ea typeface="신세계 민부리 Light(TTF)"/>
                           <a:cs typeface="신세계 민부리 Light(TTF)"/>
                         </a:rPr>
-                        <a:t>2.9조 / 20년</a:t>
+                        <a:t>2.9조</a:t>
+                      </a:r>
+                    </a:p>
+                  </a:txBody>
+                  <a:tcPr marL="40000" marR="40000" marT="0" marB="0" anchor="ctr">
+                    <a:lnL w="0">
+                      <a:noFill/>
+                    </a:lnL>
+                    <a:lnR w="0">
+                      <a:noFill/>
+                    </a:lnR>
+                    <a:lnT w="6350">
+                      <a:solidFill>
+                        <a:srgbClr val="D9D9D9"/>
+                      </a:solidFill>
+                    </a:lnT>
+                    <a:lnB w="6350">
+                      <a:solidFill>
+                        <a:srgbClr val="D9D9D9"/>
+                      </a:solidFill>
+                    </a:lnB>
+                    <a:noFill/>
+                  </a:tcPr>
+                </a:tc>
+                <a:tc>
+                  <a:txBody>
+                    <a:bodyPr wrap="square"/>
+                    <a:lstStyle/>
+                    <a:p>
+                      <a:pPr algn="ctr"/>
+                      <a:r>
+                        <a:rPr sz="850" b="0">
+                          <a:solidFill>
+                            <a:srgbClr val="000000"/>
+                          </a:solidFill>
+                          <a:latin typeface="신세계 민부리 Light(TTF)"/>
+                          <a:ea typeface="신세계 민부리 Light(TTF)"/>
+                          <a:cs typeface="신세계 민부리 Light(TTF)"/>
+                        </a:rPr>
+                        <a:t>20년</a:t>
                       </a:r>
                     </a:p>
                   </a:txBody>
@@ -5509,7 +5666,46 @@
                           <a:ea typeface="신세계 민부리 Light(TTF)"/>
                           <a:cs typeface="신세계 민부리 Light(TTF)"/>
                         </a:rPr>
-                        <a:t>6,624억 / 20년</a:t>
+                        <a:t>6,624억</a:t>
+                      </a:r>
+                    </a:p>
+                  </a:txBody>
+                  <a:tcPr marL="40000" marR="40000" marT="0" marB="0" anchor="ctr">
+                    <a:lnL w="0">
+                      <a:noFill/>
+                    </a:lnL>
+                    <a:lnR w="0">
+                      <a:noFill/>
+                    </a:lnR>
+                    <a:lnT w="6350">
+                      <a:solidFill>
+                        <a:srgbClr val="D9D9D9"/>
+                      </a:solidFill>
+                    </a:lnT>
+                    <a:lnB w="6350">
+                      <a:solidFill>
+                        <a:srgbClr val="D9D9D9"/>
+                      </a:solidFill>
+                    </a:lnB>
+                    <a:noFill/>
+                  </a:tcPr>
+                </a:tc>
+                <a:tc>
+                  <a:txBody>
+                    <a:bodyPr wrap="square"/>
+                    <a:lstStyle/>
+                    <a:p>
+                      <a:pPr algn="ctr"/>
+                      <a:r>
+                        <a:rPr sz="850" b="0">
+                          <a:solidFill>
+                            <a:srgbClr val="000000"/>
+                          </a:solidFill>
+                          <a:latin typeface="신세계 민부리 Light(TTF)"/>
+                          <a:ea typeface="신세계 민부리 Light(TTF)"/>
+                          <a:cs typeface="신세계 민부리 Light(TTF)"/>
+                        </a:rPr>
+                        <a:t>20년</a:t>
                       </a:r>
                     </a:p>
                   </a:txBody>
@@ -5784,7 +5980,46 @@
                           <a:ea typeface="신세계 민부리 Light(TTF)"/>
                           <a:cs typeface="신세계 민부리 Light(TTF)"/>
                         </a:rPr>
-                        <a:t>599억 / 3년</a:t>
+                        <a:t>599억</a:t>
+                      </a:r>
+                    </a:p>
+                  </a:txBody>
+                  <a:tcPr marL="40000" marR="40000" marT="0" marB="0" anchor="ctr">
+                    <a:lnL w="0">
+                      <a:noFill/>
+                    </a:lnL>
+                    <a:lnR w="0">
+                      <a:noFill/>
+                    </a:lnR>
+                    <a:lnT w="6350">
+                      <a:solidFill>
+                        <a:srgbClr val="D9D9D9"/>
+                      </a:solidFill>
+                    </a:lnT>
+                    <a:lnB w="6350">
+                      <a:solidFill>
+                        <a:srgbClr val="D9D9D9"/>
+                      </a:solidFill>
+                    </a:lnB>
+                    <a:noFill/>
+                  </a:tcPr>
+                </a:tc>
+                <a:tc>
+                  <a:txBody>
+                    <a:bodyPr wrap="square"/>
+                    <a:lstStyle/>
+                    <a:p>
+                      <a:pPr algn="ctr"/>
+                      <a:r>
+                        <a:rPr sz="850" b="0">
+                          <a:solidFill>
+                            <a:srgbClr val="000000"/>
+                          </a:solidFill>
+                          <a:latin typeface="신세계 민부리 Light(TTF)"/>
+                          <a:ea typeface="신세계 민부리 Light(TTF)"/>
+                          <a:cs typeface="신세계 민부리 Light(TTF)"/>
+                        </a:rPr>
+                        <a:t>3년</a:t>
                       </a:r>
                     </a:p>
                   </a:txBody>
@@ -6059,7 +6294,46 @@
                           <a:ea typeface="신세계 민부리 Light(TTF)"/>
                           <a:cs typeface="신세계 민부리 Light(TTF)"/>
                         </a:rPr>
-                        <a:t>1,397억 / 1년</a:t>
+                        <a:t>1,397억</a:t>
+                      </a:r>
+                    </a:p>
+                  </a:txBody>
+                  <a:tcPr marL="40000" marR="40000" marT="0" marB="0" anchor="ctr">
+                    <a:lnL w="0">
+                      <a:noFill/>
+                    </a:lnL>
+                    <a:lnR w="0">
+                      <a:noFill/>
+                    </a:lnR>
+                    <a:lnT w="6350">
+                      <a:solidFill>
+                        <a:srgbClr val="D9D9D9"/>
+                      </a:solidFill>
+                    </a:lnT>
+                    <a:lnB w="6350">
+                      <a:solidFill>
+                        <a:srgbClr val="D9D9D9"/>
+                      </a:solidFill>
+                    </a:lnB>
+                    <a:noFill/>
+                  </a:tcPr>
+                </a:tc>
+                <a:tc>
+                  <a:txBody>
+                    <a:bodyPr wrap="square"/>
+                    <a:lstStyle/>
+                    <a:p>
+                      <a:pPr algn="ctr"/>
+                      <a:r>
+                        <a:rPr sz="850" b="0">
+                          <a:solidFill>
+                            <a:srgbClr val="000000"/>
+                          </a:solidFill>
+                          <a:latin typeface="신세계 민부리 Light(TTF)"/>
+                          <a:ea typeface="신세계 민부리 Light(TTF)"/>
+                          <a:cs typeface="신세계 민부리 Light(TTF)"/>
+                        </a:rPr>
+                        <a:t>1년</a:t>
                       </a:r>
                     </a:p>
                   </a:txBody>
@@ -6334,7 +6608,46 @@
                           <a:ea typeface="신세계 민부리 Light(TTF)"/>
                           <a:cs typeface="신세계 민부리 Light(TTF)"/>
                         </a:rPr>
-                        <a:t>5.2조 / 20년</a:t>
+                        <a:t>5.2조</a:t>
+                      </a:r>
+                    </a:p>
+                  </a:txBody>
+                  <a:tcPr marL="40000" marR="40000" marT="0" marB="0" anchor="ctr">
+                    <a:lnL w="0">
+                      <a:noFill/>
+                    </a:lnL>
+                    <a:lnR w="0">
+                      <a:noFill/>
+                    </a:lnR>
+                    <a:lnT w="6350">
+                      <a:solidFill>
+                        <a:srgbClr val="D9D9D9"/>
+                      </a:solidFill>
+                    </a:lnT>
+                    <a:lnB w="6350">
+                      <a:solidFill>
+                        <a:srgbClr val="D9D9D9"/>
+                      </a:solidFill>
+                    </a:lnB>
+                    <a:noFill/>
+                  </a:tcPr>
+                </a:tc>
+                <a:tc>
+                  <a:txBody>
+                    <a:bodyPr wrap="square"/>
+                    <a:lstStyle/>
+                    <a:p>
+                      <a:pPr algn="ctr"/>
+                      <a:r>
+                        <a:rPr sz="850" b="0">
+                          <a:solidFill>
+                            <a:srgbClr val="000000"/>
+                          </a:solidFill>
+                          <a:latin typeface="신세계 민부리 Light(TTF)"/>
+                          <a:ea typeface="신세계 민부리 Light(TTF)"/>
+                          <a:cs typeface="신세계 민부리 Light(TTF)"/>
+                        </a:rPr>
+                        <a:t>20년</a:t>
                       </a:r>
                     </a:p>
                   </a:txBody>
@@ -6621,7 +6934,48 @@
                           <a:ea typeface="신세계 민부리 Bold(TTF)"/>
                           <a:cs typeface="신세계 민부리 Bold(TTF)"/>
                         </a:rPr>
-                        <a:t>27.7조 / 10년</a:t>
+                        <a:t>27.7조</a:t>
+                      </a:r>
+                    </a:p>
+                  </a:txBody>
+                  <a:tcPr marL="40000" marR="40000" marT="0" marB="0" anchor="ctr">
+                    <a:lnL w="0">
+                      <a:noFill/>
+                    </a:lnL>
+                    <a:lnR w="0">
+                      <a:noFill/>
+                    </a:lnR>
+                    <a:lnT w="6350">
+                      <a:solidFill>
+                        <a:srgbClr val="D9D9D9"/>
+                      </a:solidFill>
+                    </a:lnT>
+                    <a:lnB w="6350">
+                      <a:solidFill>
+                        <a:srgbClr val="D9D9D9"/>
+                      </a:solidFill>
+                    </a:lnB>
+                    <a:solidFill>
+                      <a:srgbClr val="EAF2FB"/>
+                    </a:solidFill>
+                  </a:tcPr>
+                </a:tc>
+                <a:tc>
+                  <a:txBody>
+                    <a:bodyPr wrap="square"/>
+                    <a:lstStyle/>
+                    <a:p>
+                      <a:pPr algn="ctr"/>
+                      <a:r>
+                        <a:rPr sz="850" b="1">
+                          <a:solidFill>
+                            <a:srgbClr val="002060"/>
+                          </a:solidFill>
+                          <a:latin typeface="신세계 민부리 Bold(TTF)"/>
+                          <a:ea typeface="신세계 민부리 Bold(TTF)"/>
+                          <a:cs typeface="신세계 민부리 Bold(TTF)"/>
+                        </a:rPr>
+                        <a:t>10년</a:t>
                       </a:r>
                     </a:p>
                   </a:txBody>
@@ -6936,6 +7290,47 @@
                     </a:solidFill>
                   </a:tcPr>
                 </a:tc>
+                <a:tc>
+                  <a:txBody>
+                    <a:bodyPr wrap="square"/>
+                    <a:lstStyle/>
+                    <a:p>
+                      <a:pPr algn="ctr"/>
+                      <a:r>
+                        <a:rPr sz="850" b="1">
+                          <a:solidFill>
+                            <a:srgbClr val="000000"/>
+                          </a:solidFill>
+                          <a:latin typeface="신세계 민부리 Bold(TTF)"/>
+                          <a:ea typeface="신세계 민부리 Bold(TTF)"/>
+                          <a:cs typeface="신세계 민부리 Bold(TTF)"/>
+                        </a:rPr>
+                        <a:t/>
+                      </a:r>
+                    </a:p>
+                  </a:txBody>
+                  <a:tcPr marL="40000" marR="40000" marT="0" marB="0" anchor="ctr">
+                    <a:lnL w="0">
+                      <a:noFill/>
+                    </a:lnL>
+                    <a:lnR w="0">
+                      <a:noFill/>
+                    </a:lnR>
+                    <a:lnT w="12700">
+                      <a:solidFill>
+                        <a:srgbClr val="002060"/>
+                      </a:solidFill>
+                    </a:lnT>
+                    <a:lnB w="12700">
+                      <a:solidFill>
+                        <a:srgbClr val="002060"/>
+                      </a:solidFill>
+                    </a:lnB>
+                    <a:solidFill>
+                      <a:srgbClr val="F2F2F2"/>
+                    </a:solidFill>
+                  </a:tcPr>
+                </a:tc>
               </a:tr>
             </a:tbl>
           </a:graphicData>
@@ -6957,8 +7352,8 @@
         </p:blipFill>
         <p:spPr>
           <a:xfrm>
-            <a:off x="3254000" y="5080000"/>
-            <a:ext cx="850000" cy="2000000"/>
+            <a:off x="3204000" y="5080000"/>
+            <a:ext cx="800000" cy="2000000"/>
           </a:xfrm>
           <a:prstGeom prst="rect">
             <a:avLst/>

</xml_diff>

<commit_message>
Redraw funding structure as total cost to equity breakdown diagram
Co-Authored-By: Claude Opus 5.5 <noreply@anthropic.com>
Claude-Session: https://claude.ai/code/session_01UDmzKjjdYrug7NodmfaK5P
</commit_message>
<xml_diff>
--- a/PJT_summary.pptx
+++ b/PJT_summary.pptx
@@ -7368,7 +7368,7 @@
         </p:nvSpPr>
         <p:spPr>
           <a:xfrm>
-            <a:off x="254000" y="7600000"/>
+            <a:off x="254000" y="7560000"/>
             <a:ext cx="6350000" cy="260000"/>
           </a:xfrm>
           <a:prstGeom prst="rect">
@@ -7395,634 +7395,875 @@
           </a:p>
         </p:txBody>
       </p:sp>
+      <p:grpSp>
+        <p:nvGrpSpPr>
+          <p:cNvPr id="24" name="Group 23"/>
+          <p:cNvGrpSpPr/>
+          <p:nvPr/>
+        </p:nvGrpSpPr>
+        <p:grpSpPr>
+          <a:xfrm>
+            <a:off x="254000" y="7860000"/>
+            <a:ext cx="6350000" cy="1531250"/>
+            <a:chOff x="254000" y="7860000"/>
+            <a:chExt cx="6350000" cy="1531250"/>
+          </a:xfrm>
+        </p:grpSpPr>
+        <p:sp>
+          <p:nvSpPr>
+            <p:cNvPr id="25" name="TextBox 24"/>
+            <p:cNvSpPr txBox="1"/>
+            <p:nvPr/>
+          </p:nvSpPr>
+          <p:spPr>
+            <a:xfrm>
+              <a:off x="1554000" y="7860000"/>
+              <a:ext cx="1100000" cy="200000"/>
+            </a:xfrm>
+            <a:prstGeom prst="rect">
+              <a:avLst/>
+            </a:prstGeom>
+            <a:noFill/>
+          </p:spPr>
+          <p:txBody>
+            <a:bodyPr wrap="square" anchor="ctr" lIns="0" rIns="0" tIns="0" bIns="0"/>
+            <a:lstStyle/>
+            <a:p>
+              <a:pPr algn="ctr"/>
+              <a:r>
+                <a:rPr sz="900" b="1">
+                  <a:solidFill>
+                    <a:srgbClr val="000000"/>
+                  </a:solidFill>
+                  <a:latin typeface="신세계 민부리 Bold(TTF)"/>
+                  <a:ea typeface="신세계 민부리 Bold(TTF)"/>
+                  <a:cs typeface="신세계 민부리 Bold(TTF)"/>
+                </a:rPr>
+                <a:t>총 사업비 32.8조</a:t>
+              </a:r>
+            </a:p>
+          </p:txBody>
+        </p:sp>
+        <p:sp>
+          <p:nvSpPr>
+            <p:cNvPr id="26" name="TextBox 25"/>
+            <p:cNvSpPr txBox="1"/>
+            <p:nvPr/>
+          </p:nvSpPr>
+          <p:spPr>
+            <a:xfrm>
+              <a:off x="3254000" y="7860000"/>
+              <a:ext cx="1100000" cy="200000"/>
+            </a:xfrm>
+            <a:prstGeom prst="rect">
+              <a:avLst/>
+            </a:prstGeom>
+            <a:noFill/>
+          </p:spPr>
+          <p:txBody>
+            <a:bodyPr wrap="square" anchor="ctr" lIns="0" rIns="0" tIns="0" bIns="0"/>
+            <a:lstStyle/>
+            <a:p>
+              <a:pPr algn="ctr"/>
+              <a:r>
+                <a:rPr sz="900" b="1">
+                  <a:solidFill>
+                    <a:srgbClr val="002060"/>
+                  </a:solidFill>
+                  <a:latin typeface="신세계 민부리 Bold(TTF)"/>
+                  <a:ea typeface="신세계 민부리 Bold(TTF)"/>
+                  <a:cs typeface="신세계 민부리 Bold(TTF)"/>
+                </a:rPr>
+                <a:t>Equity 10.3조</a:t>
+              </a:r>
+            </a:p>
+          </p:txBody>
+        </p:sp>
+        <p:sp>
+          <p:nvSpPr>
+            <p:cNvPr id="27" name="Rectangle 26"/>
+            <p:cNvSpPr/>
+            <p:nvPr/>
+          </p:nvSpPr>
+          <p:spPr>
+            <a:xfrm>
+              <a:off x="1754000" y="8070000"/>
+              <a:ext cx="700000" cy="387500"/>
+            </a:xfrm>
+            <a:prstGeom prst="rect">
+              <a:avLst/>
+            </a:prstGeom>
+            <a:solidFill>
+              <a:srgbClr val="002060"/>
+            </a:solidFill>
+            <a:ln w="6350">
+              <a:solidFill>
+                <a:srgbClr val="FFFFFF"/>
+              </a:solidFill>
+            </a:ln>
+            <a:effectLst/>
+          </p:spPr>
+          <p:style>
+            <a:lnRef idx="1">
+              <a:schemeClr val="accent1"/>
+            </a:lnRef>
+            <a:fillRef idx="3">
+              <a:schemeClr val="accent1"/>
+            </a:fillRef>
+            <a:effectRef idx="0">
+              <a:schemeClr val="accent1"/>
+            </a:effectRef>
+            <a:fontRef idx="minor">
+              <a:schemeClr val="lt1"/>
+            </a:fontRef>
+          </p:style>
+          <p:txBody>
+            <a:bodyPr rtlCol="0" anchor="ctr" lIns="0" rIns="0" tIns="0" bIns="0"/>
+            <a:lstStyle/>
+            <a:p>
+              <a:pPr algn="ctr"/>
+              <a:r>
+                <a:rPr sz="850" b="1">
+                  <a:solidFill>
+                    <a:srgbClr val="FFFFFF"/>
+                  </a:solidFill>
+                  <a:latin typeface="신세계 민부리 Bold(TTF)"/>
+                  <a:ea typeface="신세계 민부리 Bold(TTF)"/>
+                  <a:cs typeface="신세계 민부리 Bold(TTF)"/>
+                </a:rPr>
+                <a:t>31%</a:t>
+              </a:r>
+            </a:p>
+          </p:txBody>
+        </p:sp>
+        <p:sp>
+          <p:nvSpPr>
+            <p:cNvPr id="28" name="TextBox 27"/>
+            <p:cNvSpPr txBox="1"/>
+            <p:nvPr/>
+          </p:nvSpPr>
+          <p:spPr>
+            <a:xfrm>
+              <a:off x="254000" y="8070000"/>
+              <a:ext cx="1420000" cy="387500"/>
+            </a:xfrm>
+            <a:prstGeom prst="rect">
+              <a:avLst/>
+            </a:prstGeom>
+            <a:noFill/>
+          </p:spPr>
+          <p:txBody>
+            <a:bodyPr wrap="square" anchor="ctr" lIns="0" rIns="0" tIns="0" bIns="0"/>
+            <a:lstStyle/>
+            <a:p>
+              <a:pPr algn="r"/>
+              <a:r>
+                <a:rPr sz="850" b="1">
+                  <a:solidFill>
+                    <a:srgbClr val="002060"/>
+                  </a:solidFill>
+                  <a:latin typeface="신세계 민부리 Bold(TTF)"/>
+                  <a:ea typeface="신세계 민부리 Bold(TTF)"/>
+                  <a:cs typeface="신세계 민부리 Bold(TTF)"/>
+                </a:rPr>
+                <a:t>Equity</a:t>
+              </a:r>
+            </a:p>
+            <a:p>
+              <a:pPr algn="r"/>
+              <a:r>
+                <a:rPr sz="850" b="0">
+                  <a:solidFill>
+                    <a:srgbClr val="595959"/>
+                  </a:solidFill>
+                  <a:latin typeface="신세계 민부리 Light(TTF)"/>
+                  <a:ea typeface="신세계 민부리 Light(TTF)"/>
+                  <a:cs typeface="신세계 민부리 Light(TTF)"/>
+                </a:rPr>
+                <a:t>10.3조</a:t>
+              </a:r>
+            </a:p>
+          </p:txBody>
+        </p:sp>
+        <p:sp>
+          <p:nvSpPr>
+            <p:cNvPr id="29" name="Rectangle 28"/>
+            <p:cNvSpPr/>
+            <p:nvPr/>
+          </p:nvSpPr>
+          <p:spPr>
+            <a:xfrm>
+              <a:off x="1754000" y="8457500"/>
+              <a:ext cx="700000" cy="525000"/>
+            </a:xfrm>
+            <a:prstGeom prst="rect">
+              <a:avLst/>
+            </a:prstGeom>
+            <a:solidFill>
+              <a:srgbClr val="BFBFBF"/>
+            </a:solidFill>
+            <a:ln w="6350">
+              <a:solidFill>
+                <a:srgbClr val="FFFFFF"/>
+              </a:solidFill>
+            </a:ln>
+            <a:effectLst/>
+          </p:spPr>
+          <p:style>
+            <a:lnRef idx="1">
+              <a:schemeClr val="accent1"/>
+            </a:lnRef>
+            <a:fillRef idx="3">
+              <a:schemeClr val="accent1"/>
+            </a:fillRef>
+            <a:effectRef idx="0">
+              <a:schemeClr val="accent1"/>
+            </a:effectRef>
+            <a:fontRef idx="minor">
+              <a:schemeClr val="lt1"/>
+            </a:fontRef>
+          </p:style>
+          <p:txBody>
+            <a:bodyPr rtlCol="0" anchor="ctr" lIns="0" rIns="0" tIns="0" bIns="0"/>
+            <a:lstStyle/>
+            <a:p>
+              <a:pPr algn="ctr"/>
+              <a:r>
+                <a:rPr sz="850" b="1">
+                  <a:solidFill>
+                    <a:srgbClr val="000000"/>
+                  </a:solidFill>
+                  <a:latin typeface="신세계 민부리 Bold(TTF)"/>
+                  <a:ea typeface="신세계 민부리 Bold(TTF)"/>
+                  <a:cs typeface="신세계 민부리 Bold(TTF)"/>
+                </a:rPr>
+                <a:t>42%</a:t>
+              </a:r>
+            </a:p>
+          </p:txBody>
+        </p:sp>
+        <p:sp>
+          <p:nvSpPr>
+            <p:cNvPr id="30" name="TextBox 29"/>
+            <p:cNvSpPr txBox="1"/>
+            <p:nvPr/>
+          </p:nvSpPr>
+          <p:spPr>
+            <a:xfrm>
+              <a:off x="254000" y="8457500"/>
+              <a:ext cx="1420000" cy="525000"/>
+            </a:xfrm>
+            <a:prstGeom prst="rect">
+              <a:avLst/>
+            </a:prstGeom>
+            <a:noFill/>
+          </p:spPr>
+          <p:txBody>
+            <a:bodyPr wrap="square" anchor="ctr" lIns="0" rIns="0" tIns="0" bIns="0"/>
+            <a:lstStyle/>
+            <a:p>
+              <a:pPr algn="r"/>
+              <a:r>
+                <a:rPr sz="850" b="0">
+                  <a:solidFill>
+                    <a:srgbClr val="000000"/>
+                  </a:solidFill>
+                  <a:latin typeface="신세계 민부리 Light(TTF)"/>
+                  <a:ea typeface="신세계 민부리 Light(TTF)"/>
+                  <a:cs typeface="신세계 민부리 Light(TTF)"/>
+                </a:rPr>
+                <a:t>차입 (PF·회사채 등)</a:t>
+              </a:r>
+            </a:p>
+            <a:p>
+              <a:pPr algn="r"/>
+              <a:r>
+                <a:rPr sz="850" b="0">
+                  <a:solidFill>
+                    <a:srgbClr val="595959"/>
+                  </a:solidFill>
+                  <a:latin typeface="신세계 민부리 Light(TTF)"/>
+                  <a:ea typeface="신세계 민부리 Light(TTF)"/>
+                  <a:cs typeface="신세계 민부리 Light(TTF)"/>
+                </a:rPr>
+                <a:t>13.8조</a:t>
+              </a:r>
+            </a:p>
+          </p:txBody>
+        </p:sp>
+        <p:sp>
+          <p:nvSpPr>
+            <p:cNvPr id="31" name="Rectangle 30"/>
+            <p:cNvSpPr/>
+            <p:nvPr/>
+          </p:nvSpPr>
+          <p:spPr>
+            <a:xfrm>
+              <a:off x="1754000" y="8982500"/>
+              <a:ext cx="700000" cy="337500"/>
+            </a:xfrm>
+            <a:prstGeom prst="rect">
+              <a:avLst/>
+            </a:prstGeom>
+            <a:solidFill>
+              <a:srgbClr val="D9D9D9"/>
+            </a:solidFill>
+            <a:ln w="6350">
+              <a:solidFill>
+                <a:srgbClr val="FFFFFF"/>
+              </a:solidFill>
+            </a:ln>
+            <a:effectLst/>
+          </p:spPr>
+          <p:style>
+            <a:lnRef idx="1">
+              <a:schemeClr val="accent1"/>
+            </a:lnRef>
+            <a:fillRef idx="3">
+              <a:schemeClr val="accent1"/>
+            </a:fillRef>
+            <a:effectRef idx="0">
+              <a:schemeClr val="accent1"/>
+            </a:effectRef>
+            <a:fontRef idx="minor">
+              <a:schemeClr val="lt1"/>
+            </a:fontRef>
+          </p:style>
+          <p:txBody>
+            <a:bodyPr rtlCol="0" anchor="ctr" lIns="0" rIns="0" tIns="0" bIns="0"/>
+            <a:lstStyle/>
+            <a:p>
+              <a:pPr algn="ctr"/>
+              <a:r>
+                <a:rPr sz="850" b="1">
+                  <a:solidFill>
+                    <a:srgbClr val="000000"/>
+                  </a:solidFill>
+                  <a:latin typeface="신세계 민부리 Bold(TTF)"/>
+                  <a:ea typeface="신세계 민부리 Bold(TTF)"/>
+                  <a:cs typeface="신세계 민부리 Bold(TTF)"/>
+                </a:rPr>
+                <a:t>27%</a:t>
+              </a:r>
+            </a:p>
+          </p:txBody>
+        </p:sp>
+        <p:sp>
+          <p:nvSpPr>
+            <p:cNvPr id="32" name="TextBox 31"/>
+            <p:cNvSpPr txBox="1"/>
+            <p:nvPr/>
+          </p:nvSpPr>
+          <p:spPr>
+            <a:xfrm>
+              <a:off x="254000" y="8982500"/>
+              <a:ext cx="1420000" cy="337500"/>
+            </a:xfrm>
+            <a:prstGeom prst="rect">
+              <a:avLst/>
+            </a:prstGeom>
+            <a:noFill/>
+          </p:spPr>
+          <p:txBody>
+            <a:bodyPr wrap="square" anchor="ctr" lIns="0" rIns="0" tIns="0" bIns="0"/>
+            <a:lstStyle/>
+            <a:p>
+              <a:pPr algn="r"/>
+              <a:r>
+                <a:rPr sz="850" b="0">
+                  <a:solidFill>
+                    <a:srgbClr val="000000"/>
+                  </a:solidFill>
+                  <a:latin typeface="신세계 민부리 Light(TTF)"/>
+                  <a:ea typeface="신세계 민부리 Light(TTF)"/>
+                  <a:cs typeface="신세계 민부리 Light(TTF)"/>
+                </a:rPr>
+                <a:t>분양 · 보증금</a:t>
+              </a:r>
+            </a:p>
+            <a:p>
+              <a:pPr algn="r"/>
+              <a:r>
+                <a:rPr sz="850" b="0">
+                  <a:solidFill>
+                    <a:srgbClr val="595959"/>
+                  </a:solidFill>
+                  <a:latin typeface="신세계 민부리 Light(TTF)"/>
+                  <a:ea typeface="신세계 민부리 Light(TTF)"/>
+                  <a:cs typeface="신세계 민부리 Light(TTF)"/>
+                </a:rPr>
+                <a:t>8.7조</a:t>
+              </a:r>
+            </a:p>
+          </p:txBody>
+        </p:sp>
+        <p:sp>
+          <p:nvSpPr>
+            <p:cNvPr id="33" name="Freeform 32"/>
+            <p:cNvSpPr/>
+            <p:nvPr/>
+          </p:nvSpPr>
+          <p:spPr>
+            <a:xfrm>
+              <a:off x="2454000" y="8070000"/>
+              <a:ext cx="1000000" cy="1250000"/>
+            </a:xfrm>
+            <a:custGeom>
+              <a:avLst/>
+              <a:gdLst/>
+              <a:ahLst/>
+              <a:cxnLst/>
+              <a:rect l="l" t="t" r="r" b="b"/>
+              <a:pathLst>
+                <a:path w="1000000" h="1250000">
+                  <a:moveTo>
+                    <a:pt x="0" y="0"/>
+                  </a:moveTo>
+                  <a:lnTo>
+                    <a:pt x="1000000" y="0"/>
+                  </a:lnTo>
+                  <a:lnTo>
+                    <a:pt x="1000000" y="1250000"/>
+                  </a:lnTo>
+                  <a:lnTo>
+                    <a:pt x="0" y="387500"/>
+                  </a:lnTo>
+                  <a:close/>
+                </a:path>
+              </a:pathLst>
+            </a:custGeom>
+            <a:solidFill>
+              <a:srgbClr val="EAF2FB"/>
+            </a:solidFill>
+            <a:ln>
+              <a:noFill/>
+            </a:ln>
+          </p:spPr>
+          <p:style>
+            <a:lnRef idx="1">
+              <a:schemeClr val="accent1"/>
+            </a:lnRef>
+            <a:fillRef idx="3">
+              <a:schemeClr val="accent1"/>
+            </a:fillRef>
+            <a:effectRef idx="0">
+              <a:schemeClr val="accent1"/>
+            </a:effectRef>
+            <a:fontRef idx="minor">
+              <a:schemeClr val="lt1"/>
+            </a:fontRef>
+          </p:style>
+          <p:txBody>
+            <a:bodyPr rtlCol="0" anchor="ctr"/>
+            <a:lstStyle/>
+            <a:p>
+              <a:pPr algn="ctr"/>
+            </a:p>
+          </p:txBody>
+        </p:sp>
+        <p:sp>
+          <p:nvSpPr>
+            <p:cNvPr id="34" name="Rectangle 33"/>
+            <p:cNvSpPr/>
+            <p:nvPr/>
+          </p:nvSpPr>
+          <p:spPr>
+            <a:xfrm>
+              <a:off x="3454000" y="8070000"/>
+              <a:ext cx="700000" cy="912500"/>
+            </a:xfrm>
+            <a:prstGeom prst="rect">
+              <a:avLst/>
+            </a:prstGeom>
+            <a:solidFill>
+              <a:srgbClr val="002060"/>
+            </a:solidFill>
+            <a:ln w="6350">
+              <a:solidFill>
+                <a:srgbClr val="FFFFFF"/>
+              </a:solidFill>
+            </a:ln>
+            <a:effectLst/>
+          </p:spPr>
+          <p:style>
+            <a:lnRef idx="1">
+              <a:schemeClr val="accent1"/>
+            </a:lnRef>
+            <a:fillRef idx="3">
+              <a:schemeClr val="accent1"/>
+            </a:fillRef>
+            <a:effectRef idx="0">
+              <a:schemeClr val="accent1"/>
+            </a:effectRef>
+            <a:fontRef idx="minor">
+              <a:schemeClr val="lt1"/>
+            </a:fontRef>
+          </p:style>
+          <p:txBody>
+            <a:bodyPr rtlCol="0" anchor="ctr" lIns="0" rIns="0" tIns="0" bIns="0"/>
+            <a:lstStyle/>
+            <a:p>
+              <a:pPr algn="ctr"/>
+              <a:r>
+                <a:rPr sz="850" b="1">
+                  <a:solidFill>
+                    <a:srgbClr val="FFFFFF"/>
+                  </a:solidFill>
+                  <a:latin typeface="신세계 민부리 Bold(TTF)"/>
+                  <a:ea typeface="신세계 민부리 Bold(TTF)"/>
+                  <a:cs typeface="신세계 민부리 Bold(TTF)"/>
+                </a:rPr>
+                <a:t>73%</a:t>
+              </a:r>
+            </a:p>
+          </p:txBody>
+        </p:sp>
+        <p:sp>
+          <p:nvSpPr>
+            <p:cNvPr id="35" name="TextBox 34"/>
+            <p:cNvSpPr txBox="1"/>
+            <p:nvPr/>
+          </p:nvSpPr>
+          <p:spPr>
+            <a:xfrm>
+              <a:off x="4224000" y="8436250"/>
+              <a:ext cx="920000" cy="180000"/>
+            </a:xfrm>
+            <a:prstGeom prst="rect">
+              <a:avLst/>
+            </a:prstGeom>
+            <a:noFill/>
+          </p:spPr>
+          <p:txBody>
+            <a:bodyPr wrap="square" anchor="ctr" lIns="0" rIns="0" tIns="0" bIns="0"/>
+            <a:lstStyle/>
+            <a:p>
+              <a:pPr algn="l"/>
+              <a:r>
+                <a:rPr sz="850" b="1">
+                  <a:solidFill>
+                    <a:srgbClr val="000000"/>
+                  </a:solidFill>
+                  <a:latin typeface="신세계 민부리 Bold(TTF)"/>
+                  <a:ea typeface="신세계 민부리 Bold(TTF)"/>
+                  <a:cs typeface="신세계 민부리 Bold(TTF)"/>
+                </a:rPr>
+                <a:t>당사 7.5조</a:t>
+              </a:r>
+            </a:p>
+          </p:txBody>
+        </p:sp>
+        <p:sp>
+          <p:nvSpPr>
+            <p:cNvPr id="36" name="Rectangle 35"/>
+            <p:cNvSpPr/>
+            <p:nvPr/>
+          </p:nvSpPr>
+          <p:spPr>
+            <a:xfrm>
+              <a:off x="3454000" y="8982500"/>
+              <a:ext cx="700000" cy="250000"/>
+            </a:xfrm>
+            <a:prstGeom prst="rect">
+              <a:avLst/>
+            </a:prstGeom>
+            <a:solidFill>
+              <a:srgbClr val="5B7FB5"/>
+            </a:solidFill>
+            <a:ln w="6350">
+              <a:solidFill>
+                <a:srgbClr val="FFFFFF"/>
+              </a:solidFill>
+            </a:ln>
+            <a:effectLst/>
+          </p:spPr>
+          <p:style>
+            <a:lnRef idx="1">
+              <a:schemeClr val="accent1"/>
+            </a:lnRef>
+            <a:fillRef idx="3">
+              <a:schemeClr val="accent1"/>
+            </a:fillRef>
+            <a:effectRef idx="0">
+              <a:schemeClr val="accent1"/>
+            </a:effectRef>
+            <a:fontRef idx="minor">
+              <a:schemeClr val="lt1"/>
+            </a:fontRef>
+          </p:style>
+          <p:txBody>
+            <a:bodyPr rtlCol="0" anchor="ctr" lIns="0" rIns="0" tIns="0" bIns="0"/>
+            <a:lstStyle/>
+            <a:p>
+              <a:pPr algn="ctr"/>
+              <a:r>
+                <a:rPr sz="850" b="1">
+                  <a:solidFill>
+                    <a:srgbClr val="FFFFFF"/>
+                  </a:solidFill>
+                  <a:latin typeface="신세계 민부리 Bold(TTF)"/>
+                  <a:ea typeface="신세계 민부리 Bold(TTF)"/>
+                  <a:cs typeface="신세계 민부리 Bold(TTF)"/>
+                </a:rPr>
+                <a:t>20%</a:t>
+              </a:r>
+            </a:p>
+          </p:txBody>
+        </p:sp>
+        <p:sp>
+          <p:nvSpPr>
+            <p:cNvPr id="37" name="TextBox 36"/>
+            <p:cNvSpPr txBox="1"/>
+            <p:nvPr/>
+          </p:nvSpPr>
+          <p:spPr>
+            <a:xfrm>
+              <a:off x="4224000" y="8987500"/>
+              <a:ext cx="920000" cy="180000"/>
+            </a:xfrm>
+            <a:prstGeom prst="rect">
+              <a:avLst/>
+            </a:prstGeom>
+            <a:noFill/>
+          </p:spPr>
+          <p:txBody>
+            <a:bodyPr wrap="square" anchor="ctr" lIns="0" rIns="0" tIns="0" bIns="0"/>
+            <a:lstStyle/>
+            <a:p>
+              <a:pPr algn="l"/>
+              <a:r>
+                <a:rPr sz="850" b="1">
+                  <a:solidFill>
+                    <a:srgbClr val="000000"/>
+                  </a:solidFill>
+                  <a:latin typeface="신세계 민부리 Bold(TTF)"/>
+                  <a:ea typeface="신세계 민부리 Bold(TTF)"/>
+                  <a:cs typeface="신세계 민부리 Bold(TTF)"/>
+                </a:rPr>
+                <a:t>百 2.0조</a:t>
+              </a:r>
+            </a:p>
+          </p:txBody>
+        </p:sp>
+        <p:sp>
+          <p:nvSpPr>
+            <p:cNvPr id="38" name="Rectangle 37"/>
+            <p:cNvSpPr/>
+            <p:nvPr/>
+          </p:nvSpPr>
+          <p:spPr>
+            <a:xfrm>
+              <a:off x="3454000" y="9232500"/>
+              <a:ext cx="700000" cy="87500"/>
+            </a:xfrm>
+            <a:prstGeom prst="rect">
+              <a:avLst/>
+            </a:prstGeom>
+            <a:solidFill>
+              <a:srgbClr val="D9D9D9"/>
+            </a:solidFill>
+            <a:ln w="6350">
+              <a:solidFill>
+                <a:srgbClr val="FFFFFF"/>
+              </a:solidFill>
+            </a:ln>
+            <a:effectLst/>
+          </p:spPr>
+          <p:style>
+            <a:lnRef idx="1">
+              <a:schemeClr val="accent1"/>
+            </a:lnRef>
+            <a:fillRef idx="3">
+              <a:schemeClr val="accent1"/>
+            </a:fillRef>
+            <a:effectRef idx="0">
+              <a:schemeClr val="accent1"/>
+            </a:effectRef>
+            <a:fontRef idx="minor">
+              <a:schemeClr val="lt1"/>
+            </a:fontRef>
+          </p:style>
+          <p:txBody>
+            <a:bodyPr rtlCol="0" anchor="ctr"/>
+            <a:lstStyle/>
+            <a:p>
+              <a:pPr algn="ctr"/>
+            </a:p>
+          </p:txBody>
+        </p:sp>
+        <p:sp>
+          <p:nvSpPr>
+            <p:cNvPr id="39" name="TextBox 38"/>
+            <p:cNvSpPr txBox="1"/>
+            <p:nvPr/>
+          </p:nvSpPr>
+          <p:spPr>
+            <a:xfrm>
+              <a:off x="4224000" y="9211250"/>
+              <a:ext cx="920000" cy="180000"/>
+            </a:xfrm>
+            <a:prstGeom prst="rect">
+              <a:avLst/>
+            </a:prstGeom>
+            <a:noFill/>
+          </p:spPr>
+          <p:txBody>
+            <a:bodyPr wrap="square" anchor="ctr" lIns="0" rIns="0" tIns="0" bIns="0"/>
+            <a:lstStyle/>
+            <a:p>
+              <a:pPr algn="l"/>
+              <a:r>
+                <a:rPr sz="750" b="0">
+                  <a:solidFill>
+                    <a:srgbClr val="595959"/>
+                  </a:solidFill>
+                  <a:latin typeface="신세계 민부리 Light(TTF)"/>
+                  <a:ea typeface="신세계 민부리 Light(TTF)"/>
+                  <a:cs typeface="신세계 민부리 Light(TTF)"/>
+                </a:rPr>
+                <a:t>외부 0.8조 (7%)</a:t>
+              </a:r>
+            </a:p>
+          </p:txBody>
+        </p:sp>
+        <p:sp>
+          <p:nvSpPr>
+            <p:cNvPr id="40" name="Right Brace 39"/>
+            <p:cNvSpPr/>
+            <p:nvPr/>
+          </p:nvSpPr>
+          <p:spPr>
+            <a:xfrm>
+              <a:off x="5154000" y="8070000"/>
+              <a:ext cx="90000" cy="1162500"/>
+            </a:xfrm>
+            <a:prstGeom prst="rightBrace">
+              <a:avLst/>
+            </a:prstGeom>
+            <a:noFill/>
+            <a:ln w="12700">
+              <a:solidFill>
+                <a:srgbClr val="002060"/>
+              </a:solidFill>
+            </a:ln>
+          </p:spPr>
+          <p:style>
+            <a:lnRef idx="1">
+              <a:schemeClr val="accent1"/>
+            </a:lnRef>
+            <a:fillRef idx="3">
+              <a:schemeClr val="accent1"/>
+            </a:fillRef>
+            <a:effectRef idx="0">
+              <a:schemeClr val="accent1"/>
+            </a:effectRef>
+            <a:fontRef idx="minor">
+              <a:schemeClr val="lt1"/>
+            </a:fontRef>
+          </p:style>
+          <p:txBody>
+            <a:bodyPr rtlCol="0" anchor="ctr"/>
+            <a:lstStyle/>
+            <a:p>
+              <a:pPr algn="ctr"/>
+            </a:p>
+          </p:txBody>
+        </p:sp>
+        <p:sp>
+          <p:nvSpPr>
+            <p:cNvPr id="41" name="TextBox 40"/>
+            <p:cNvSpPr txBox="1"/>
+            <p:nvPr/>
+          </p:nvSpPr>
+          <p:spPr>
+            <a:xfrm>
+              <a:off x="5294000" y="8070000"/>
+              <a:ext cx="1310000" cy="1162500"/>
+            </a:xfrm>
+            <a:prstGeom prst="rect">
+              <a:avLst/>
+            </a:prstGeom>
+            <a:noFill/>
+          </p:spPr>
+          <p:txBody>
+            <a:bodyPr wrap="square" anchor="ctr" lIns="0" rIns="0" tIns="0" bIns="0"/>
+            <a:lstStyle/>
+            <a:p>
+              <a:pPr algn="l"/>
+              <a:r>
+                <a:rPr sz="900" b="0">
+                  <a:solidFill>
+                    <a:srgbClr val="595959"/>
+                  </a:solidFill>
+                  <a:latin typeface="신세계 민부리 Light(TTF)"/>
+                  <a:ea typeface="신세계 민부리 Light(TTF)"/>
+                  <a:cs typeface="신세계 민부리 Light(TTF)"/>
+                </a:rPr>
+                <a:t>신세계 Equity</a:t>
+              </a:r>
+            </a:p>
+            <a:p>
+              <a:pPr algn="l">
+                <a:spcBef>
+                  <a:spcPts val="200"/>
+                </a:spcBef>
+              </a:pPr>
+              <a:r>
+                <a:rPr sz="1600" b="1">
+                  <a:solidFill>
+                    <a:srgbClr val="002060"/>
+                  </a:solidFill>
+                  <a:latin typeface="신세계 민부리 Bold(TTF)"/>
+                  <a:ea typeface="신세계 민부리 Bold(TTF)"/>
+                  <a:cs typeface="신세계 민부리 Bold(TTF)"/>
+                </a:rPr>
+                <a:t>9.5조</a:t>
+              </a:r>
+            </a:p>
+            <a:p>
+              <a:pPr algn="l">
+                <a:spcBef>
+                  <a:spcPts val="200"/>
+                </a:spcBef>
+              </a:pPr>
+              <a:r>
+                <a:rPr sz="850" b="1">
+                  <a:solidFill>
+                    <a:srgbClr val="000000"/>
+                  </a:solidFill>
+                  <a:latin typeface="신세계 민부리 Bold(TTF)"/>
+                  <a:ea typeface="신세계 민부리 Bold(TTF)"/>
+                  <a:cs typeface="신세계 민부리 Bold(TTF)"/>
+                </a:rPr>
+                <a:t>Equity의 93%</a:t>
+              </a:r>
+            </a:p>
+            <a:p>
+              <a:pPr algn="l"/>
+              <a:r>
+                <a:rPr sz="850" b="0">
+                  <a:solidFill>
+                    <a:srgbClr val="595959"/>
+                  </a:solidFill>
+                  <a:latin typeface="신세계 민부리 Light(TTF)"/>
+                  <a:ea typeface="신세계 민부리 Light(TTF)"/>
+                  <a:cs typeface="신세계 민부리 Light(TTF)"/>
+                </a:rPr>
+                <a:t>총 사업비 대비 29%</a:t>
+              </a:r>
+            </a:p>
+          </p:txBody>
+        </p:sp>
+      </p:grpSp>
       <p:sp>
         <p:nvSpPr>
-          <p:cNvPr id="24" name="TextBox 23"/>
+          <p:cNvPr id="42" name="TextBox 41"/>
           <p:cNvSpPr txBox="1"/>
           <p:nvPr/>
         </p:nvSpPr>
         <p:spPr>
           <a:xfrm>
-            <a:off x="254000" y="7960000"/>
-            <a:ext cx="1150000" cy="300000"/>
-          </a:xfrm>
-          <a:prstGeom prst="rect">
-            <a:avLst/>
-          </a:prstGeom>
-          <a:noFill/>
-        </p:spPr>
-        <p:txBody>
-          <a:bodyPr wrap="square" anchor="ctr" lIns="0" rIns="0" tIns="0" bIns="0"/>
-          <a:lstStyle/>
-          <a:p>
-            <a:pPr algn="l"/>
-            <a:r>
-              <a:rPr sz="900" b="1">
-                <a:solidFill>
-                  <a:srgbClr val="000000"/>
-                </a:solidFill>
-                <a:latin typeface="신세계 민부리 Bold(TTF)"/>
-                <a:ea typeface="신세계 민부리 Bold(TTF)"/>
-                <a:cs typeface="신세계 민부리 Bold(TTF)"/>
-              </a:rPr>
-              <a:t>총 사업비</a:t>
-            </a:r>
-          </a:p>
-          <a:p>
-            <a:pPr algn="l"/>
-            <a:r>
-              <a:rPr sz="800" b="0">
-                <a:solidFill>
-                  <a:srgbClr val="595959"/>
-                </a:solidFill>
-                <a:latin typeface="신세계 민부리 Light(TTF)"/>
-                <a:ea typeface="신세계 민부리 Light(TTF)"/>
-                <a:cs typeface="신세계 민부리 Light(TTF)"/>
-              </a:rPr>
-              <a:t>32.8조</a:t>
-            </a:r>
-          </a:p>
-        </p:txBody>
-      </p:sp>
-      <p:sp>
-        <p:nvSpPr>
-          <p:cNvPr id="25" name="Rectangle 24"/>
-          <p:cNvSpPr/>
-          <p:nvPr/>
-        </p:nvSpPr>
-        <p:spPr>
-          <a:xfrm>
-            <a:off x="1404000" y="7960000"/>
-            <a:ext cx="1612000" cy="300000"/>
-          </a:xfrm>
-          <a:prstGeom prst="rect">
-            <a:avLst/>
-          </a:prstGeom>
-          <a:solidFill>
-            <a:srgbClr val="002060"/>
-          </a:solidFill>
-          <a:ln w="6350">
-            <a:solidFill>
-              <a:srgbClr val="FFFFFF"/>
-            </a:solidFill>
-          </a:ln>
-          <a:effectLst/>
-        </p:spPr>
-        <p:style>
-          <a:lnRef idx="1">
-            <a:schemeClr val="accent1"/>
-          </a:lnRef>
-          <a:fillRef idx="3">
-            <a:schemeClr val="accent1"/>
-          </a:fillRef>
-          <a:effectRef idx="0">
-            <a:schemeClr val="accent1"/>
-          </a:effectRef>
-          <a:fontRef idx="minor">
-            <a:schemeClr val="lt1"/>
-          </a:fontRef>
-        </p:style>
-        <p:txBody>
-          <a:bodyPr rtlCol="0" anchor="ctr"/>
-          <a:lstStyle/>
-          <a:p>
-            <a:pPr algn="ctr"/>
-          </a:p>
-        </p:txBody>
-      </p:sp>
-      <p:sp>
-        <p:nvSpPr>
-          <p:cNvPr id="26" name="TextBox 25"/>
-          <p:cNvSpPr txBox="1"/>
-          <p:nvPr/>
-        </p:nvSpPr>
-        <p:spPr>
-          <a:xfrm>
-            <a:off x="1404000" y="7960000"/>
-            <a:ext cx="1612000" cy="300000"/>
-          </a:xfrm>
-          <a:prstGeom prst="rect">
-            <a:avLst/>
-          </a:prstGeom>
-          <a:noFill/>
-        </p:spPr>
-        <p:txBody>
-          <a:bodyPr wrap="square" anchor="ctr" lIns="0" rIns="0" tIns="0" bIns="0"/>
-          <a:lstStyle/>
-          <a:p>
-            <a:pPr algn="ctr"/>
-            <a:r>
-              <a:rPr sz="800" b="1">
-                <a:solidFill>
-                  <a:srgbClr val="FFFFFF"/>
-                </a:solidFill>
-                <a:latin typeface="신세계 민부리 Bold(TTF)"/>
-                <a:ea typeface="신세계 민부리 Bold(TTF)"/>
-                <a:cs typeface="신세계 민부리 Bold(TTF)"/>
-              </a:rPr>
-              <a:t>Equity 10.3조 (31%)</a:t>
-            </a:r>
-          </a:p>
-        </p:txBody>
-      </p:sp>
-      <p:sp>
-        <p:nvSpPr>
-          <p:cNvPr id="27" name="Rectangle 26"/>
-          <p:cNvSpPr/>
-          <p:nvPr/>
-        </p:nvSpPr>
-        <p:spPr>
-          <a:xfrm>
-            <a:off x="3016000" y="7960000"/>
-            <a:ext cx="2184000" cy="300000"/>
-          </a:xfrm>
-          <a:prstGeom prst="rect">
-            <a:avLst/>
-          </a:prstGeom>
-          <a:solidFill>
-            <a:srgbClr val="5B7FB5"/>
-          </a:solidFill>
-          <a:ln w="6350">
-            <a:solidFill>
-              <a:srgbClr val="FFFFFF"/>
-            </a:solidFill>
-          </a:ln>
-          <a:effectLst/>
-        </p:spPr>
-        <p:style>
-          <a:lnRef idx="1">
-            <a:schemeClr val="accent1"/>
-          </a:lnRef>
-          <a:fillRef idx="3">
-            <a:schemeClr val="accent1"/>
-          </a:fillRef>
-          <a:effectRef idx="0">
-            <a:schemeClr val="accent1"/>
-          </a:effectRef>
-          <a:fontRef idx="minor">
-            <a:schemeClr val="lt1"/>
-          </a:fontRef>
-        </p:style>
-        <p:txBody>
-          <a:bodyPr rtlCol="0" anchor="ctr"/>
-          <a:lstStyle/>
-          <a:p>
-            <a:pPr algn="ctr"/>
-          </a:p>
-        </p:txBody>
-      </p:sp>
-      <p:sp>
-        <p:nvSpPr>
-          <p:cNvPr id="28" name="TextBox 27"/>
-          <p:cNvSpPr txBox="1"/>
-          <p:nvPr/>
-        </p:nvSpPr>
-        <p:spPr>
-          <a:xfrm>
-            <a:off x="3016000" y="7960000"/>
-            <a:ext cx="2184000" cy="300000"/>
-          </a:xfrm>
-          <a:prstGeom prst="rect">
-            <a:avLst/>
-          </a:prstGeom>
-          <a:noFill/>
-        </p:spPr>
-        <p:txBody>
-          <a:bodyPr wrap="square" anchor="ctr" lIns="0" rIns="0" tIns="0" bIns="0"/>
-          <a:lstStyle/>
-          <a:p>
-            <a:pPr algn="ctr"/>
-            <a:r>
-              <a:rPr sz="800" b="1">
-                <a:solidFill>
-                  <a:srgbClr val="FFFFFF"/>
-                </a:solidFill>
-                <a:latin typeface="신세계 민부리 Bold(TTF)"/>
-                <a:ea typeface="신세계 민부리 Bold(TTF)"/>
-                <a:cs typeface="신세계 민부리 Bold(TTF)"/>
-              </a:rPr>
-              <a:t>차입(PF·회사채 등) 13.8조 (42%)</a:t>
-            </a:r>
-          </a:p>
-        </p:txBody>
-      </p:sp>
-      <p:sp>
-        <p:nvSpPr>
-          <p:cNvPr id="29" name="Rectangle 28"/>
-          <p:cNvSpPr/>
-          <p:nvPr/>
-        </p:nvSpPr>
-        <p:spPr>
-          <a:xfrm>
-            <a:off x="5200000" y="7960000"/>
-            <a:ext cx="1404000" cy="300000"/>
-          </a:xfrm>
-          <a:prstGeom prst="rect">
-            <a:avLst/>
-          </a:prstGeom>
-          <a:solidFill>
-            <a:srgbClr val="D9D9D9"/>
-          </a:solidFill>
-          <a:ln w="6350">
-            <a:solidFill>
-              <a:srgbClr val="FFFFFF"/>
-            </a:solidFill>
-          </a:ln>
-          <a:effectLst/>
-        </p:spPr>
-        <p:style>
-          <a:lnRef idx="1">
-            <a:schemeClr val="accent1"/>
-          </a:lnRef>
-          <a:fillRef idx="3">
-            <a:schemeClr val="accent1"/>
-          </a:fillRef>
-          <a:effectRef idx="0">
-            <a:schemeClr val="accent1"/>
-          </a:effectRef>
-          <a:fontRef idx="minor">
-            <a:schemeClr val="lt1"/>
-          </a:fontRef>
-        </p:style>
-        <p:txBody>
-          <a:bodyPr rtlCol="0" anchor="ctr"/>
-          <a:lstStyle/>
-          <a:p>
-            <a:pPr algn="ctr"/>
-          </a:p>
-        </p:txBody>
-      </p:sp>
-      <p:sp>
-        <p:nvSpPr>
-          <p:cNvPr id="30" name="TextBox 29"/>
-          <p:cNvSpPr txBox="1"/>
-          <p:nvPr/>
-        </p:nvSpPr>
-        <p:spPr>
-          <a:xfrm>
-            <a:off x="5200000" y="7960000"/>
-            <a:ext cx="1404000" cy="300000"/>
-          </a:xfrm>
-          <a:prstGeom prst="rect">
-            <a:avLst/>
-          </a:prstGeom>
-          <a:noFill/>
-        </p:spPr>
-        <p:txBody>
-          <a:bodyPr wrap="square" anchor="ctr" lIns="0" rIns="0" tIns="0" bIns="0"/>
-          <a:lstStyle/>
-          <a:p>
-            <a:pPr algn="ctr"/>
-            <a:r>
-              <a:rPr sz="800" b="1">
-                <a:solidFill>
-                  <a:srgbClr val="000000"/>
-                </a:solidFill>
-                <a:latin typeface="신세계 민부리 Bold(TTF)"/>
-                <a:ea typeface="신세계 민부리 Bold(TTF)"/>
-                <a:cs typeface="신세계 민부리 Bold(TTF)"/>
-              </a:rPr>
-              <a:t>분양·보증금 8.7조 (27%)</a:t>
-            </a:r>
-          </a:p>
-        </p:txBody>
-      </p:sp>
-      <p:sp>
-        <p:nvSpPr>
-          <p:cNvPr id="31" name="TextBox 30"/>
-          <p:cNvSpPr txBox="1"/>
-          <p:nvPr/>
-        </p:nvSpPr>
-        <p:spPr>
-          <a:xfrm>
-            <a:off x="254000" y="8380000"/>
-            <a:ext cx="1150000" cy="300000"/>
-          </a:xfrm>
-          <a:prstGeom prst="rect">
-            <a:avLst/>
-          </a:prstGeom>
-          <a:noFill/>
-        </p:spPr>
-        <p:txBody>
-          <a:bodyPr wrap="square" anchor="ctr" lIns="0" rIns="0" tIns="0" bIns="0"/>
-          <a:lstStyle/>
-          <a:p>
-            <a:pPr algn="l"/>
-            <a:r>
-              <a:rPr sz="900" b="1">
-                <a:solidFill>
-                  <a:srgbClr val="000000"/>
-                </a:solidFill>
-                <a:latin typeface="신세계 민부리 Bold(TTF)"/>
-                <a:ea typeface="신세계 민부리 Bold(TTF)"/>
-                <a:cs typeface="신세계 민부리 Bold(TTF)"/>
-              </a:rPr>
-              <a:t>Equity 구성</a:t>
-            </a:r>
-          </a:p>
-          <a:p>
-            <a:pPr algn="l"/>
-            <a:r>
-              <a:rPr sz="800" b="0">
-                <a:solidFill>
-                  <a:srgbClr val="595959"/>
-                </a:solidFill>
-                <a:latin typeface="신세계 민부리 Light(TTF)"/>
-                <a:ea typeface="신세계 민부리 Light(TTF)"/>
-                <a:cs typeface="신세계 민부리 Light(TTF)"/>
-              </a:rPr>
-              <a:t>10.3조</a:t>
-            </a:r>
-          </a:p>
-        </p:txBody>
-      </p:sp>
-      <p:sp>
-        <p:nvSpPr>
-          <p:cNvPr id="32" name="Rectangle 31"/>
-          <p:cNvSpPr/>
-          <p:nvPr/>
-        </p:nvSpPr>
-        <p:spPr>
-          <a:xfrm>
-            <a:off x="1404000" y="8380000"/>
-            <a:ext cx="3796000" cy="300000"/>
-          </a:xfrm>
-          <a:prstGeom prst="rect">
-            <a:avLst/>
-          </a:prstGeom>
-          <a:solidFill>
-            <a:srgbClr val="002060"/>
-          </a:solidFill>
-          <a:ln w="6350">
-            <a:solidFill>
-              <a:srgbClr val="FFFFFF"/>
-            </a:solidFill>
-          </a:ln>
-          <a:effectLst/>
-        </p:spPr>
-        <p:style>
-          <a:lnRef idx="1">
-            <a:schemeClr val="accent1"/>
-          </a:lnRef>
-          <a:fillRef idx="3">
-            <a:schemeClr val="accent1"/>
-          </a:fillRef>
-          <a:effectRef idx="0">
-            <a:schemeClr val="accent1"/>
-          </a:effectRef>
-          <a:fontRef idx="minor">
-            <a:schemeClr val="lt1"/>
-          </a:fontRef>
-        </p:style>
-        <p:txBody>
-          <a:bodyPr rtlCol="0" anchor="ctr"/>
-          <a:lstStyle/>
-          <a:p>
-            <a:pPr algn="ctr"/>
-          </a:p>
-        </p:txBody>
-      </p:sp>
-      <p:sp>
-        <p:nvSpPr>
-          <p:cNvPr id="33" name="TextBox 32"/>
-          <p:cNvSpPr txBox="1"/>
-          <p:nvPr/>
-        </p:nvSpPr>
-        <p:spPr>
-          <a:xfrm>
-            <a:off x="1404000" y="8380000"/>
-            <a:ext cx="3796000" cy="300000"/>
-          </a:xfrm>
-          <a:prstGeom prst="rect">
-            <a:avLst/>
-          </a:prstGeom>
-          <a:noFill/>
-        </p:spPr>
-        <p:txBody>
-          <a:bodyPr wrap="square" anchor="ctr" lIns="0" rIns="0" tIns="0" bIns="0"/>
-          <a:lstStyle/>
-          <a:p>
-            <a:pPr algn="ctr"/>
-            <a:r>
-              <a:rPr sz="800" b="1">
-                <a:solidFill>
-                  <a:srgbClr val="FFFFFF"/>
-                </a:solidFill>
-                <a:latin typeface="신세계 민부리 Bold(TTF)"/>
-                <a:ea typeface="신세계 민부리 Bold(TTF)"/>
-                <a:cs typeface="신세계 민부리 Bold(TTF)"/>
-              </a:rPr>
-              <a:t>당사 7.5조 (73%)</a:t>
-            </a:r>
-          </a:p>
-        </p:txBody>
-      </p:sp>
-      <p:sp>
-        <p:nvSpPr>
-          <p:cNvPr id="34" name="Rectangle 33"/>
-          <p:cNvSpPr/>
-          <p:nvPr/>
-        </p:nvSpPr>
-        <p:spPr>
-          <a:xfrm>
-            <a:off x="5200000" y="8380000"/>
-            <a:ext cx="1040000" cy="300000"/>
-          </a:xfrm>
-          <a:prstGeom prst="rect">
-            <a:avLst/>
-          </a:prstGeom>
-          <a:solidFill>
-            <a:srgbClr val="B4D4F0"/>
-          </a:solidFill>
-          <a:ln w="6350">
-            <a:solidFill>
-              <a:srgbClr val="FFFFFF"/>
-            </a:solidFill>
-          </a:ln>
-          <a:effectLst/>
-        </p:spPr>
-        <p:style>
-          <a:lnRef idx="1">
-            <a:schemeClr val="accent1"/>
-          </a:lnRef>
-          <a:fillRef idx="3">
-            <a:schemeClr val="accent1"/>
-          </a:fillRef>
-          <a:effectRef idx="0">
-            <a:schemeClr val="accent1"/>
-          </a:effectRef>
-          <a:fontRef idx="minor">
-            <a:schemeClr val="lt1"/>
-          </a:fontRef>
-        </p:style>
-        <p:txBody>
-          <a:bodyPr rtlCol="0" anchor="ctr"/>
-          <a:lstStyle/>
-          <a:p>
-            <a:pPr algn="ctr"/>
-          </a:p>
-        </p:txBody>
-      </p:sp>
-      <p:sp>
-        <p:nvSpPr>
-          <p:cNvPr id="35" name="TextBox 34"/>
-          <p:cNvSpPr txBox="1"/>
-          <p:nvPr/>
-        </p:nvSpPr>
-        <p:spPr>
-          <a:xfrm>
-            <a:off x="5200000" y="8380000"/>
-            <a:ext cx="1040000" cy="300000"/>
-          </a:xfrm>
-          <a:prstGeom prst="rect">
-            <a:avLst/>
-          </a:prstGeom>
-          <a:noFill/>
-        </p:spPr>
-        <p:txBody>
-          <a:bodyPr wrap="square" anchor="ctr" lIns="0" rIns="0" tIns="0" bIns="0"/>
-          <a:lstStyle/>
-          <a:p>
-            <a:pPr algn="ctr"/>
-            <a:r>
-              <a:rPr sz="800" b="1">
-                <a:solidFill>
-                  <a:srgbClr val="000000"/>
-                </a:solidFill>
-                <a:latin typeface="신세계 민부리 Bold(TTF)"/>
-                <a:ea typeface="신세계 민부리 Bold(TTF)"/>
-                <a:cs typeface="신세계 민부리 Bold(TTF)"/>
-              </a:rPr>
-              <a:t>百 2.0조 (20%)</a:t>
-            </a:r>
-          </a:p>
-        </p:txBody>
-      </p:sp>
-      <p:sp>
-        <p:nvSpPr>
-          <p:cNvPr id="36" name="Rectangle 35"/>
-          <p:cNvSpPr/>
-          <p:nvPr/>
-        </p:nvSpPr>
-        <p:spPr>
-          <a:xfrm>
-            <a:off x="6240000" y="8380000"/>
-            <a:ext cx="364000" cy="300000"/>
-          </a:xfrm>
-          <a:prstGeom prst="rect">
-            <a:avLst/>
-          </a:prstGeom>
-          <a:solidFill>
-            <a:srgbClr val="D9D9D9"/>
-          </a:solidFill>
-          <a:ln w="6350">
-            <a:solidFill>
-              <a:srgbClr val="FFFFFF"/>
-            </a:solidFill>
-          </a:ln>
-          <a:effectLst/>
-        </p:spPr>
-        <p:style>
-          <a:lnRef idx="1">
-            <a:schemeClr val="accent1"/>
-          </a:lnRef>
-          <a:fillRef idx="3">
-            <a:schemeClr val="accent1"/>
-          </a:fillRef>
-          <a:effectRef idx="0">
-            <a:schemeClr val="accent1"/>
-          </a:effectRef>
-          <a:fontRef idx="minor">
-            <a:schemeClr val="lt1"/>
-          </a:fontRef>
-        </p:style>
-        <p:txBody>
-          <a:bodyPr rtlCol="0" anchor="ctr"/>
-          <a:lstStyle/>
-          <a:p>
-            <a:pPr algn="ctr"/>
-          </a:p>
-        </p:txBody>
-      </p:sp>
-      <p:sp>
-        <p:nvSpPr>
-          <p:cNvPr id="37" name="TextBox 36"/>
-          <p:cNvSpPr txBox="1"/>
-          <p:nvPr/>
-        </p:nvSpPr>
-        <p:spPr>
-          <a:xfrm>
-            <a:off x="6240000" y="8380000"/>
-            <a:ext cx="364000" cy="300000"/>
-          </a:xfrm>
-          <a:prstGeom prst="rect">
-            <a:avLst/>
-          </a:prstGeom>
-          <a:noFill/>
-        </p:spPr>
-        <p:txBody>
-          <a:bodyPr wrap="square" anchor="ctr" lIns="0" rIns="0" tIns="0" bIns="0"/>
-          <a:lstStyle/>
-          <a:p>
-            <a:pPr algn="ctr"/>
-            <a:r>
-              <a:rPr sz="700" b="1">
-                <a:solidFill>
-                  <a:srgbClr val="000000"/>
-                </a:solidFill>
-                <a:latin typeface="신세계 민부리 Bold(TTF)"/>
-                <a:ea typeface="신세계 민부리 Bold(TTF)"/>
-                <a:cs typeface="신세계 민부리 Bold(TTF)"/>
-              </a:rPr>
-              <a:t>외부 7%</a:t>
-            </a:r>
-          </a:p>
-        </p:txBody>
-      </p:sp>
-      <p:sp>
-        <p:nvSpPr>
-          <p:cNvPr id="38" name="TextBox 37"/>
-          <p:cNvSpPr txBox="1"/>
-          <p:nvPr/>
-        </p:nvSpPr>
-        <p:spPr>
-          <a:xfrm>
-            <a:off x="254000" y="8770000"/>
-            <a:ext cx="6350000" cy="230000"/>
-          </a:xfrm>
-          <a:prstGeom prst="rect">
-            <a:avLst/>
-          </a:prstGeom>
-          <a:noFill/>
-        </p:spPr>
-        <p:txBody>
-          <a:bodyPr wrap="square" anchor="ctr" lIns="0" rIns="0" tIns="0" bIns="0"/>
-          <a:lstStyle/>
-          <a:p>
-            <a:pPr algn="l"/>
-            <a:r>
-              <a:rPr sz="900" b="0">
-                <a:solidFill>
-                  <a:srgbClr val="000000"/>
-                </a:solidFill>
-                <a:latin typeface="신세계 민부리 Light(TTF)"/>
-                <a:ea typeface="신세계 민부리 Light(TTF)"/>
-                <a:cs typeface="신세계 민부리 Light(TTF)"/>
-              </a:rPr>
-              <a:t>→ 신세계(당사+百)가 Equity의 93%(9.5조)를 부담하며, 이는 총 사업비의 29% 수준</a:t>
-            </a:r>
-          </a:p>
-        </p:txBody>
-      </p:sp>
-      <p:sp>
-        <p:nvSpPr>
-          <p:cNvPr id="39" name="TextBox 38"/>
-          <p:cNvSpPr txBox="1"/>
-          <p:nvPr/>
-        </p:nvSpPr>
-        <p:spPr>
-          <a:xfrm>
-            <a:off x="254000" y="9500000"/>
+            <a:off x="254000" y="9560000"/>
             <a:ext cx="6350000" cy="300000"/>
           </a:xfrm>
           <a:prstGeom prst="rect">

</xml_diff>

<commit_message>
Replace funding structure with PJT profitability section
Co-Authored-By: Claude Opus 5.5 <noreply@anthropic.com>
Claude-Session: https://claude.ai/code/session_01UDmzKjjdYrug7NodmfaK5P
</commit_message>
<xml_diff>
--- a/PJT_summary.pptx
+++ b/PJT_summary.pptx
@@ -7390,881 +7390,1692 @@
                 <a:ea typeface="신세계 민부리 Bold(TTF)"/>
                 <a:cs typeface="신세계 민부리 Bold(TTF)"/>
               </a:rPr>
-              <a:t>❍  사업비 조달 구조</a:t>
+              <a:t>❍  PJT 수익성 (안정화 시점)</a:t>
             </a:r>
           </a:p>
         </p:txBody>
       </p:sp>
-      <p:grpSp>
-        <p:nvGrpSpPr>
-          <p:cNvPr id="24" name="Group 23"/>
-          <p:cNvGrpSpPr/>
+      <p:cxnSp>
+        <p:nvCxnSpPr>
+          <p:cNvPr id="24" name="Connector 23"/>
+          <p:cNvCxnSpPr/>
           <p:nvPr/>
-        </p:nvGrpSpPr>
-        <p:grpSpPr>
+        </p:nvCxnSpPr>
+        <p:spPr>
           <a:xfrm>
-            <a:off x="254000" y="7860000"/>
-            <a:ext cx="6350000" cy="1531250"/>
-            <a:chOff x="254000" y="7860000"/>
-            <a:chExt cx="6350000" cy="1531250"/>
+            <a:off x="254000" y="7890000"/>
+            <a:ext cx="1450000" cy="0"/>
           </a:xfrm>
-        </p:grpSpPr>
-        <p:sp>
-          <p:nvSpPr>
-            <p:cNvPr id="25" name="TextBox 24"/>
-            <p:cNvSpPr txBox="1"/>
-            <p:nvPr/>
-          </p:nvSpPr>
-          <p:spPr>
-            <a:xfrm>
-              <a:off x="1554000" y="7860000"/>
-              <a:ext cx="1100000" cy="200000"/>
-            </a:xfrm>
-            <a:prstGeom prst="rect">
-              <a:avLst/>
-            </a:prstGeom>
-            <a:noFill/>
-          </p:spPr>
-          <p:txBody>
-            <a:bodyPr wrap="square" anchor="ctr" lIns="0" rIns="0" tIns="0" bIns="0"/>
-            <a:lstStyle/>
-            <a:p>
-              <a:pPr algn="ctr"/>
-              <a:r>
-                <a:rPr sz="900" b="1">
-                  <a:solidFill>
-                    <a:srgbClr val="000000"/>
-                  </a:solidFill>
-                  <a:latin typeface="신세계 민부리 Bold(TTF)"/>
-                  <a:ea typeface="신세계 민부리 Bold(TTF)"/>
-                  <a:cs typeface="신세계 민부리 Bold(TTF)"/>
-                </a:rPr>
-                <a:t>총 사업비 32.8조</a:t>
-              </a:r>
-            </a:p>
-          </p:txBody>
-        </p:sp>
-        <p:sp>
-          <p:nvSpPr>
-            <p:cNvPr id="26" name="TextBox 25"/>
-            <p:cNvSpPr txBox="1"/>
-            <p:nvPr/>
-          </p:nvSpPr>
-          <p:spPr>
-            <a:xfrm>
-              <a:off x="3254000" y="7860000"/>
-              <a:ext cx="1100000" cy="200000"/>
-            </a:xfrm>
-            <a:prstGeom prst="rect">
-              <a:avLst/>
-            </a:prstGeom>
-            <a:noFill/>
-          </p:spPr>
-          <p:txBody>
-            <a:bodyPr wrap="square" anchor="ctr" lIns="0" rIns="0" tIns="0" bIns="0"/>
-            <a:lstStyle/>
-            <a:p>
-              <a:pPr algn="ctr"/>
-              <a:r>
-                <a:rPr sz="900" b="1">
-                  <a:solidFill>
-                    <a:srgbClr val="002060"/>
-                  </a:solidFill>
-                  <a:latin typeface="신세계 민부리 Bold(TTF)"/>
-                  <a:ea typeface="신세계 민부리 Bold(TTF)"/>
-                  <a:cs typeface="신세계 민부리 Bold(TTF)"/>
-                </a:rPr>
-                <a:t>Equity 10.3조</a:t>
-              </a:r>
-            </a:p>
-          </p:txBody>
-        </p:sp>
-        <p:sp>
-          <p:nvSpPr>
-            <p:cNvPr id="27" name="Rectangle 26"/>
-            <p:cNvSpPr/>
-            <p:nvPr/>
-          </p:nvSpPr>
-          <p:spPr>
-            <a:xfrm>
-              <a:off x="1754000" y="8070000"/>
-              <a:ext cx="700000" cy="387500"/>
-            </a:xfrm>
-            <a:prstGeom prst="rect">
-              <a:avLst/>
-            </a:prstGeom>
+          <a:prstGeom prst="line">
+            <a:avLst/>
+          </a:prstGeom>
+          <a:ln w="19050">
             <a:solidFill>
               <a:srgbClr val="002060"/>
             </a:solidFill>
-            <a:ln w="6350">
-              <a:solidFill>
-                <a:srgbClr val="FFFFFF"/>
-              </a:solidFill>
-            </a:ln>
-            <a:effectLst/>
-          </p:spPr>
-          <p:style>
-            <a:lnRef idx="1">
-              <a:schemeClr val="accent1"/>
-            </a:lnRef>
-            <a:fillRef idx="3">
-              <a:schemeClr val="accent1"/>
-            </a:fillRef>
-            <a:effectRef idx="0">
-              <a:schemeClr val="accent1"/>
-            </a:effectRef>
-            <a:fontRef idx="minor">
-              <a:schemeClr val="lt1"/>
-            </a:fontRef>
-          </p:style>
-          <p:txBody>
-            <a:bodyPr rtlCol="0" anchor="ctr" lIns="0" rIns="0" tIns="0" bIns="0"/>
-            <a:lstStyle/>
-            <a:p>
-              <a:pPr algn="ctr"/>
-              <a:r>
-                <a:rPr sz="850" b="1">
-                  <a:solidFill>
-                    <a:srgbClr val="FFFFFF"/>
-                  </a:solidFill>
-                  <a:latin typeface="신세계 민부리 Bold(TTF)"/>
-                  <a:ea typeface="신세계 민부리 Bold(TTF)"/>
-                  <a:cs typeface="신세계 민부리 Bold(TTF)"/>
-                </a:rPr>
-                <a:t>31%</a:t>
-              </a:r>
-            </a:p>
-          </p:txBody>
-        </p:sp>
-        <p:sp>
-          <p:nvSpPr>
-            <p:cNvPr id="28" name="TextBox 27"/>
-            <p:cNvSpPr txBox="1"/>
-            <p:nvPr/>
-          </p:nvSpPr>
-          <p:spPr>
-            <a:xfrm>
-              <a:off x="254000" y="8070000"/>
-              <a:ext cx="1420000" cy="387500"/>
-            </a:xfrm>
-            <a:prstGeom prst="rect">
-              <a:avLst/>
-            </a:prstGeom>
-            <a:noFill/>
-          </p:spPr>
-          <p:txBody>
-            <a:bodyPr wrap="square" anchor="ctr" lIns="0" rIns="0" tIns="0" bIns="0"/>
-            <a:lstStyle/>
-            <a:p>
-              <a:pPr algn="r"/>
-              <a:r>
-                <a:rPr sz="850" b="1">
-                  <a:solidFill>
-                    <a:srgbClr val="002060"/>
-                  </a:solidFill>
-                  <a:latin typeface="신세계 민부리 Bold(TTF)"/>
-                  <a:ea typeface="신세계 민부리 Bold(TTF)"/>
-                  <a:cs typeface="신세계 민부리 Bold(TTF)"/>
-                </a:rPr>
-                <a:t>Equity</a:t>
-              </a:r>
-            </a:p>
-            <a:p>
-              <a:pPr algn="r"/>
-              <a:r>
-                <a:rPr sz="850" b="0">
-                  <a:solidFill>
-                    <a:srgbClr val="595959"/>
-                  </a:solidFill>
-                  <a:latin typeface="신세계 민부리 Light(TTF)"/>
-                  <a:ea typeface="신세계 민부리 Light(TTF)"/>
-                  <a:cs typeface="신세계 민부리 Light(TTF)"/>
-                </a:rPr>
-                <a:t>10.3조</a:t>
-              </a:r>
-            </a:p>
-          </p:txBody>
-        </p:sp>
-        <p:sp>
-          <p:nvSpPr>
-            <p:cNvPr id="29" name="Rectangle 28"/>
-            <p:cNvSpPr/>
-            <p:nvPr/>
-          </p:nvSpPr>
-          <p:spPr>
-            <a:xfrm>
-              <a:off x="1754000" y="8457500"/>
-              <a:ext cx="700000" cy="525000"/>
-            </a:xfrm>
-            <a:prstGeom prst="rect">
-              <a:avLst/>
-            </a:prstGeom>
-            <a:solidFill>
-              <a:srgbClr val="BFBFBF"/>
-            </a:solidFill>
-            <a:ln w="6350">
-              <a:solidFill>
-                <a:srgbClr val="FFFFFF"/>
-              </a:solidFill>
-            </a:ln>
-            <a:effectLst/>
-          </p:spPr>
-          <p:style>
-            <a:lnRef idx="1">
-              <a:schemeClr val="accent1"/>
-            </a:lnRef>
-            <a:fillRef idx="3">
-              <a:schemeClr val="accent1"/>
-            </a:fillRef>
-            <a:effectRef idx="0">
-              <a:schemeClr val="accent1"/>
-            </a:effectRef>
-            <a:fontRef idx="minor">
-              <a:schemeClr val="lt1"/>
-            </a:fontRef>
-          </p:style>
-          <p:txBody>
-            <a:bodyPr rtlCol="0" anchor="ctr" lIns="0" rIns="0" tIns="0" bIns="0"/>
-            <a:lstStyle/>
-            <a:p>
-              <a:pPr algn="ctr"/>
-              <a:r>
-                <a:rPr sz="850" b="1">
-                  <a:solidFill>
-                    <a:srgbClr val="000000"/>
-                  </a:solidFill>
-                  <a:latin typeface="신세계 민부리 Bold(TTF)"/>
-                  <a:ea typeface="신세계 민부리 Bold(TTF)"/>
-                  <a:cs typeface="신세계 민부리 Bold(TTF)"/>
-                </a:rPr>
-                <a:t>42%</a:t>
-              </a:r>
-            </a:p>
-          </p:txBody>
-        </p:sp>
-        <p:sp>
-          <p:nvSpPr>
-            <p:cNvPr id="30" name="TextBox 29"/>
-            <p:cNvSpPr txBox="1"/>
-            <p:nvPr/>
-          </p:nvSpPr>
-          <p:spPr>
-            <a:xfrm>
-              <a:off x="254000" y="8457500"/>
-              <a:ext cx="1420000" cy="525000"/>
-            </a:xfrm>
-            <a:prstGeom prst="rect">
-              <a:avLst/>
-            </a:prstGeom>
-            <a:noFill/>
-          </p:spPr>
-          <p:txBody>
-            <a:bodyPr wrap="square" anchor="ctr" lIns="0" rIns="0" tIns="0" bIns="0"/>
-            <a:lstStyle/>
-            <a:p>
-              <a:pPr algn="r"/>
-              <a:r>
-                <a:rPr sz="850" b="0">
-                  <a:solidFill>
-                    <a:srgbClr val="000000"/>
-                  </a:solidFill>
-                  <a:latin typeface="신세계 민부리 Light(TTF)"/>
-                  <a:ea typeface="신세계 민부리 Light(TTF)"/>
-                  <a:cs typeface="신세계 민부리 Light(TTF)"/>
-                </a:rPr>
-                <a:t>차입 (PF·회사채 등)</a:t>
-              </a:r>
-            </a:p>
-            <a:p>
-              <a:pPr algn="r"/>
-              <a:r>
-                <a:rPr sz="850" b="0">
-                  <a:solidFill>
-                    <a:srgbClr val="595959"/>
-                  </a:solidFill>
-                  <a:latin typeface="신세계 민부리 Light(TTF)"/>
-                  <a:ea typeface="신세계 민부리 Light(TTF)"/>
-                  <a:cs typeface="신세계 민부리 Light(TTF)"/>
-                </a:rPr>
-                <a:t>13.8조</a:t>
-              </a:r>
-            </a:p>
-          </p:txBody>
-        </p:sp>
-        <p:sp>
-          <p:nvSpPr>
-            <p:cNvPr id="31" name="Rectangle 30"/>
-            <p:cNvSpPr/>
-            <p:nvPr/>
-          </p:nvSpPr>
-          <p:spPr>
-            <a:xfrm>
-              <a:off x="1754000" y="8982500"/>
-              <a:ext cx="700000" cy="337500"/>
-            </a:xfrm>
-            <a:prstGeom prst="rect">
-              <a:avLst/>
-            </a:prstGeom>
-            <a:solidFill>
-              <a:srgbClr val="D9D9D9"/>
-            </a:solidFill>
-            <a:ln w="6350">
-              <a:solidFill>
-                <a:srgbClr val="FFFFFF"/>
-              </a:solidFill>
-            </a:ln>
-            <a:effectLst/>
-          </p:spPr>
-          <p:style>
-            <a:lnRef idx="1">
-              <a:schemeClr val="accent1"/>
-            </a:lnRef>
-            <a:fillRef idx="3">
-              <a:schemeClr val="accent1"/>
-            </a:fillRef>
-            <a:effectRef idx="0">
-              <a:schemeClr val="accent1"/>
-            </a:effectRef>
-            <a:fontRef idx="minor">
-              <a:schemeClr val="lt1"/>
-            </a:fontRef>
-          </p:style>
-          <p:txBody>
-            <a:bodyPr rtlCol="0" anchor="ctr" lIns="0" rIns="0" tIns="0" bIns="0"/>
-            <a:lstStyle/>
-            <a:p>
-              <a:pPr algn="ctr"/>
-              <a:r>
-                <a:rPr sz="850" b="1">
-                  <a:solidFill>
-                    <a:srgbClr val="000000"/>
-                  </a:solidFill>
-                  <a:latin typeface="신세계 민부리 Bold(TTF)"/>
-                  <a:ea typeface="신세계 민부리 Bold(TTF)"/>
-                  <a:cs typeface="신세계 민부리 Bold(TTF)"/>
-                </a:rPr>
-                <a:t>27%</a:t>
-              </a:r>
-            </a:p>
-          </p:txBody>
-        </p:sp>
-        <p:sp>
-          <p:nvSpPr>
-            <p:cNvPr id="32" name="TextBox 31"/>
-            <p:cNvSpPr txBox="1"/>
-            <p:nvPr/>
-          </p:nvSpPr>
-          <p:spPr>
-            <a:xfrm>
-              <a:off x="254000" y="8982500"/>
-              <a:ext cx="1420000" cy="337500"/>
-            </a:xfrm>
-            <a:prstGeom prst="rect">
-              <a:avLst/>
-            </a:prstGeom>
-            <a:noFill/>
-          </p:spPr>
-          <p:txBody>
-            <a:bodyPr wrap="square" anchor="ctr" lIns="0" rIns="0" tIns="0" bIns="0"/>
-            <a:lstStyle/>
-            <a:p>
-              <a:pPr algn="r"/>
-              <a:r>
-                <a:rPr sz="850" b="0">
-                  <a:solidFill>
-                    <a:srgbClr val="000000"/>
-                  </a:solidFill>
-                  <a:latin typeface="신세계 민부리 Light(TTF)"/>
-                  <a:ea typeface="신세계 민부리 Light(TTF)"/>
-                  <a:cs typeface="신세계 민부리 Light(TTF)"/>
-                </a:rPr>
-                <a:t>분양 · 보증금</a:t>
-              </a:r>
-            </a:p>
-            <a:p>
-              <a:pPr algn="r"/>
-              <a:r>
-                <a:rPr sz="850" b="0">
-                  <a:solidFill>
-                    <a:srgbClr val="595959"/>
-                  </a:solidFill>
-                  <a:latin typeface="신세계 민부리 Light(TTF)"/>
-                  <a:ea typeface="신세계 민부리 Light(TTF)"/>
-                  <a:cs typeface="신세계 민부리 Light(TTF)"/>
-                </a:rPr>
-                <a:t>8.7조</a:t>
-              </a:r>
-            </a:p>
-          </p:txBody>
-        </p:sp>
-        <p:sp>
-          <p:nvSpPr>
-            <p:cNvPr id="33" name="Freeform 32"/>
-            <p:cNvSpPr/>
-            <p:nvPr/>
-          </p:nvSpPr>
-          <p:spPr>
-            <a:xfrm>
-              <a:off x="2454000" y="8070000"/>
-              <a:ext cx="1000000" cy="1250000"/>
-            </a:xfrm>
-            <a:custGeom>
-              <a:avLst/>
-              <a:gdLst/>
-              <a:ahLst/>
-              <a:cxnLst/>
-              <a:rect l="l" t="t" r="r" b="b"/>
-              <a:pathLst>
-                <a:path w="1000000" h="1250000">
-                  <a:moveTo>
-                    <a:pt x="0" y="0"/>
-                  </a:moveTo>
-                  <a:lnTo>
-                    <a:pt x="1000000" y="0"/>
-                  </a:lnTo>
-                  <a:lnTo>
-                    <a:pt x="1000000" y="1250000"/>
-                  </a:lnTo>
-                  <a:lnTo>
-                    <a:pt x="0" y="387500"/>
-                  </a:lnTo>
-                  <a:close/>
-                </a:path>
-              </a:pathLst>
-            </a:custGeom>
-            <a:solidFill>
-              <a:srgbClr val="EAF2FB"/>
-            </a:solidFill>
-            <a:ln>
-              <a:noFill/>
-            </a:ln>
-          </p:spPr>
-          <p:style>
-            <a:lnRef idx="1">
-              <a:schemeClr val="accent1"/>
-            </a:lnRef>
-            <a:fillRef idx="3">
-              <a:schemeClr val="accent1"/>
-            </a:fillRef>
-            <a:effectRef idx="0">
-              <a:schemeClr val="accent1"/>
-            </a:effectRef>
-            <a:fontRef idx="minor">
-              <a:schemeClr val="lt1"/>
-            </a:fontRef>
-          </p:style>
-          <p:txBody>
-            <a:bodyPr rtlCol="0" anchor="ctr"/>
-            <a:lstStyle/>
-            <a:p>
-              <a:pPr algn="ctr"/>
-            </a:p>
-          </p:txBody>
-        </p:sp>
-        <p:sp>
-          <p:nvSpPr>
-            <p:cNvPr id="34" name="Rectangle 33"/>
-            <p:cNvSpPr/>
-            <p:nvPr/>
-          </p:nvSpPr>
-          <p:spPr>
-            <a:xfrm>
-              <a:off x="3454000" y="8070000"/>
-              <a:ext cx="700000" cy="912500"/>
-            </a:xfrm>
-            <a:prstGeom prst="rect">
-              <a:avLst/>
-            </a:prstGeom>
-            <a:solidFill>
-              <a:srgbClr val="002060"/>
-            </a:solidFill>
-            <a:ln w="6350">
-              <a:solidFill>
-                <a:srgbClr val="FFFFFF"/>
-              </a:solidFill>
-            </a:ln>
-            <a:effectLst/>
-          </p:spPr>
-          <p:style>
-            <a:lnRef idx="1">
-              <a:schemeClr val="accent1"/>
-            </a:lnRef>
-            <a:fillRef idx="3">
-              <a:schemeClr val="accent1"/>
-            </a:fillRef>
-            <a:effectRef idx="0">
-              <a:schemeClr val="accent1"/>
-            </a:effectRef>
-            <a:fontRef idx="minor">
-              <a:schemeClr val="lt1"/>
-            </a:fontRef>
-          </p:style>
-          <p:txBody>
-            <a:bodyPr rtlCol="0" anchor="ctr" lIns="0" rIns="0" tIns="0" bIns="0"/>
-            <a:lstStyle/>
-            <a:p>
-              <a:pPr algn="ctr"/>
-              <a:r>
-                <a:rPr sz="850" b="1">
-                  <a:solidFill>
-                    <a:srgbClr val="FFFFFF"/>
-                  </a:solidFill>
-                  <a:latin typeface="신세계 민부리 Bold(TTF)"/>
-                  <a:ea typeface="신세계 민부리 Bold(TTF)"/>
-                  <a:cs typeface="신세계 민부리 Bold(TTF)"/>
-                </a:rPr>
-                <a:t>73%</a:t>
-              </a:r>
-            </a:p>
-          </p:txBody>
-        </p:sp>
-        <p:sp>
-          <p:nvSpPr>
-            <p:cNvPr id="35" name="TextBox 34"/>
-            <p:cNvSpPr txBox="1"/>
-            <p:nvPr/>
-          </p:nvSpPr>
-          <p:spPr>
-            <a:xfrm>
-              <a:off x="4224000" y="8436250"/>
-              <a:ext cx="920000" cy="180000"/>
-            </a:xfrm>
-            <a:prstGeom prst="rect">
-              <a:avLst/>
-            </a:prstGeom>
-            <a:noFill/>
-          </p:spPr>
-          <p:txBody>
-            <a:bodyPr wrap="square" anchor="ctr" lIns="0" rIns="0" tIns="0" bIns="0"/>
-            <a:lstStyle/>
-            <a:p>
-              <a:pPr algn="l"/>
-              <a:r>
-                <a:rPr sz="850" b="1">
-                  <a:solidFill>
-                    <a:srgbClr val="000000"/>
-                  </a:solidFill>
-                  <a:latin typeface="신세계 민부리 Bold(TTF)"/>
-                  <a:ea typeface="신세계 민부리 Bold(TTF)"/>
-                  <a:cs typeface="신세계 민부리 Bold(TTF)"/>
-                </a:rPr>
-                <a:t>당사 7.5조</a:t>
-              </a:r>
-            </a:p>
-          </p:txBody>
-        </p:sp>
-        <p:sp>
-          <p:nvSpPr>
-            <p:cNvPr id="36" name="Rectangle 35"/>
-            <p:cNvSpPr/>
-            <p:nvPr/>
-          </p:nvSpPr>
-          <p:spPr>
-            <a:xfrm>
-              <a:off x="3454000" y="8982500"/>
-              <a:ext cx="700000" cy="250000"/>
-            </a:xfrm>
-            <a:prstGeom prst="rect">
-              <a:avLst/>
-            </a:prstGeom>
-            <a:solidFill>
-              <a:srgbClr val="5B7FB5"/>
-            </a:solidFill>
-            <a:ln w="6350">
-              <a:solidFill>
-                <a:srgbClr val="FFFFFF"/>
-              </a:solidFill>
-            </a:ln>
-            <a:effectLst/>
-          </p:spPr>
-          <p:style>
-            <a:lnRef idx="1">
-              <a:schemeClr val="accent1"/>
-            </a:lnRef>
-            <a:fillRef idx="3">
-              <a:schemeClr val="accent1"/>
-            </a:fillRef>
-            <a:effectRef idx="0">
-              <a:schemeClr val="accent1"/>
-            </a:effectRef>
-            <a:fontRef idx="minor">
-              <a:schemeClr val="lt1"/>
-            </a:fontRef>
-          </p:style>
-          <p:txBody>
-            <a:bodyPr rtlCol="0" anchor="ctr" lIns="0" rIns="0" tIns="0" bIns="0"/>
-            <a:lstStyle/>
-            <a:p>
-              <a:pPr algn="ctr"/>
-              <a:r>
-                <a:rPr sz="850" b="1">
-                  <a:solidFill>
-                    <a:srgbClr val="FFFFFF"/>
-                  </a:solidFill>
-                  <a:latin typeface="신세계 민부리 Bold(TTF)"/>
-                  <a:ea typeface="신세계 민부리 Bold(TTF)"/>
-                  <a:cs typeface="신세계 민부리 Bold(TTF)"/>
-                </a:rPr>
-                <a:t>20%</a:t>
-              </a:r>
-            </a:p>
-          </p:txBody>
-        </p:sp>
-        <p:sp>
-          <p:nvSpPr>
-            <p:cNvPr id="37" name="TextBox 36"/>
-            <p:cNvSpPr txBox="1"/>
-            <p:nvPr/>
-          </p:nvSpPr>
-          <p:spPr>
-            <a:xfrm>
-              <a:off x="4224000" y="8987500"/>
-              <a:ext cx="920000" cy="180000"/>
-            </a:xfrm>
-            <a:prstGeom prst="rect">
-              <a:avLst/>
-            </a:prstGeom>
-            <a:noFill/>
-          </p:spPr>
-          <p:txBody>
-            <a:bodyPr wrap="square" anchor="ctr" lIns="0" rIns="0" tIns="0" bIns="0"/>
-            <a:lstStyle/>
-            <a:p>
-              <a:pPr algn="l"/>
-              <a:r>
-                <a:rPr sz="850" b="1">
-                  <a:solidFill>
-                    <a:srgbClr val="000000"/>
-                  </a:solidFill>
-                  <a:latin typeface="신세계 민부리 Bold(TTF)"/>
-                  <a:ea typeface="신세계 민부리 Bold(TTF)"/>
-                  <a:cs typeface="신세계 민부리 Bold(TTF)"/>
-                </a:rPr>
-                <a:t>百 2.0조</a:t>
-              </a:r>
-            </a:p>
-          </p:txBody>
-        </p:sp>
-        <p:sp>
-          <p:nvSpPr>
-            <p:cNvPr id="38" name="Rectangle 37"/>
-            <p:cNvSpPr/>
-            <p:nvPr/>
-          </p:nvSpPr>
-          <p:spPr>
-            <a:xfrm>
-              <a:off x="3454000" y="9232500"/>
-              <a:ext cx="700000" cy="87500"/>
-            </a:xfrm>
-            <a:prstGeom prst="rect">
-              <a:avLst/>
-            </a:prstGeom>
-            <a:solidFill>
-              <a:srgbClr val="D9D9D9"/>
-            </a:solidFill>
-            <a:ln w="6350">
-              <a:solidFill>
-                <a:srgbClr val="FFFFFF"/>
-              </a:solidFill>
-            </a:ln>
-            <a:effectLst/>
-          </p:spPr>
-          <p:style>
-            <a:lnRef idx="1">
-              <a:schemeClr val="accent1"/>
-            </a:lnRef>
-            <a:fillRef idx="3">
-              <a:schemeClr val="accent1"/>
-            </a:fillRef>
-            <a:effectRef idx="0">
-              <a:schemeClr val="accent1"/>
-            </a:effectRef>
-            <a:fontRef idx="minor">
-              <a:schemeClr val="lt1"/>
-            </a:fontRef>
-          </p:style>
-          <p:txBody>
-            <a:bodyPr rtlCol="0" anchor="ctr"/>
-            <a:lstStyle/>
-            <a:p>
-              <a:pPr algn="ctr"/>
-            </a:p>
-          </p:txBody>
-        </p:sp>
-        <p:sp>
-          <p:nvSpPr>
-            <p:cNvPr id="39" name="TextBox 38"/>
-            <p:cNvSpPr txBox="1"/>
-            <p:nvPr/>
-          </p:nvSpPr>
-          <p:spPr>
-            <a:xfrm>
-              <a:off x="4224000" y="9211250"/>
-              <a:ext cx="920000" cy="180000"/>
-            </a:xfrm>
-            <a:prstGeom prst="rect">
-              <a:avLst/>
-            </a:prstGeom>
-            <a:noFill/>
-          </p:spPr>
-          <p:txBody>
-            <a:bodyPr wrap="square" anchor="ctr" lIns="0" rIns="0" tIns="0" bIns="0"/>
-            <a:lstStyle/>
-            <a:p>
-              <a:pPr algn="l"/>
-              <a:r>
-                <a:rPr sz="750" b="0">
-                  <a:solidFill>
-                    <a:srgbClr val="595959"/>
-                  </a:solidFill>
-                  <a:latin typeface="신세계 민부리 Light(TTF)"/>
-                  <a:ea typeface="신세계 민부리 Light(TTF)"/>
-                  <a:cs typeface="신세계 민부리 Light(TTF)"/>
-                </a:rPr>
-                <a:t>외부 0.8조 (7%)</a:t>
-              </a:r>
-            </a:p>
-          </p:txBody>
-        </p:sp>
-        <p:sp>
-          <p:nvSpPr>
-            <p:cNvPr id="40" name="Right Brace 39"/>
-            <p:cNvSpPr/>
-            <p:nvPr/>
-          </p:nvSpPr>
-          <p:spPr>
-            <a:xfrm>
-              <a:off x="5154000" y="8070000"/>
-              <a:ext cx="90000" cy="1162500"/>
-            </a:xfrm>
-            <a:prstGeom prst="rightBrace">
-              <a:avLst/>
-            </a:prstGeom>
-            <a:noFill/>
-            <a:ln w="12700">
-              <a:solidFill>
-                <a:srgbClr val="002060"/>
-              </a:solidFill>
-            </a:ln>
-          </p:spPr>
-          <p:style>
-            <a:lnRef idx="1">
-              <a:schemeClr val="accent1"/>
-            </a:lnRef>
-            <a:fillRef idx="3">
-              <a:schemeClr val="accent1"/>
-            </a:fillRef>
-            <a:effectRef idx="0">
-              <a:schemeClr val="accent1"/>
-            </a:effectRef>
-            <a:fontRef idx="minor">
-              <a:schemeClr val="lt1"/>
-            </a:fontRef>
-          </p:style>
-          <p:txBody>
-            <a:bodyPr rtlCol="0" anchor="ctr"/>
-            <a:lstStyle/>
-            <a:p>
-              <a:pPr algn="ctr"/>
-            </a:p>
-          </p:txBody>
-        </p:sp>
-        <p:sp>
-          <p:nvSpPr>
-            <p:cNvPr id="41" name="TextBox 40"/>
-            <p:cNvSpPr txBox="1"/>
-            <p:nvPr/>
-          </p:nvSpPr>
-          <p:spPr>
-            <a:xfrm>
-              <a:off x="5294000" y="8070000"/>
-              <a:ext cx="1310000" cy="1162500"/>
-            </a:xfrm>
-            <a:prstGeom prst="rect">
-              <a:avLst/>
-            </a:prstGeom>
-            <a:noFill/>
-          </p:spPr>
-          <p:txBody>
-            <a:bodyPr wrap="square" anchor="ctr" lIns="0" rIns="0" tIns="0" bIns="0"/>
-            <a:lstStyle/>
-            <a:p>
-              <a:pPr algn="l"/>
-              <a:r>
-                <a:rPr sz="900" b="0">
-                  <a:solidFill>
-                    <a:srgbClr val="595959"/>
-                  </a:solidFill>
-                  <a:latin typeface="신세계 민부리 Light(TTF)"/>
-                  <a:ea typeface="신세계 민부리 Light(TTF)"/>
-                  <a:cs typeface="신세계 민부리 Light(TTF)"/>
-                </a:rPr>
-                <a:t>신세계 Equity</a:t>
-              </a:r>
-            </a:p>
-            <a:p>
-              <a:pPr algn="l">
-                <a:spcBef>
-                  <a:spcPts val="200"/>
-                </a:spcBef>
-              </a:pPr>
-              <a:r>
-                <a:rPr sz="1600" b="1">
-                  <a:solidFill>
-                    <a:srgbClr val="002060"/>
-                  </a:solidFill>
-                  <a:latin typeface="신세계 민부리 Bold(TTF)"/>
-                  <a:ea typeface="신세계 민부리 Bold(TTF)"/>
-                  <a:cs typeface="신세계 민부리 Bold(TTF)"/>
-                </a:rPr>
-                <a:t>9.5조</a:t>
-              </a:r>
-            </a:p>
-            <a:p>
-              <a:pPr algn="l">
-                <a:spcBef>
-                  <a:spcPts val="200"/>
-                </a:spcBef>
-              </a:pPr>
-              <a:r>
-                <a:rPr sz="850" b="1">
-                  <a:solidFill>
-                    <a:srgbClr val="000000"/>
-                  </a:solidFill>
-                  <a:latin typeface="신세계 민부리 Bold(TTF)"/>
-                  <a:ea typeface="신세계 민부리 Bold(TTF)"/>
-                  <a:cs typeface="신세계 민부리 Bold(TTF)"/>
-                </a:rPr>
-                <a:t>Equity의 93%</a:t>
-              </a:r>
-            </a:p>
-            <a:p>
-              <a:pPr algn="l"/>
-              <a:r>
-                <a:rPr sz="850" b="0">
-                  <a:solidFill>
-                    <a:srgbClr val="595959"/>
-                  </a:solidFill>
-                  <a:latin typeface="신세계 민부리 Light(TTF)"/>
-                  <a:ea typeface="신세계 민부리 Light(TTF)"/>
-                  <a:cs typeface="신세계 민부리 Light(TTF)"/>
-                </a:rPr>
-                <a:t>총 사업비 대비 29%</a:t>
-              </a:r>
-            </a:p>
-          </p:txBody>
-        </p:sp>
-      </p:grpSp>
+          </a:ln>
+        </p:spPr>
+        <p:style>
+          <a:lnRef idx="2">
+            <a:schemeClr val="accent1"/>
+          </a:lnRef>
+          <a:fillRef idx="0">
+            <a:schemeClr val="accent1"/>
+          </a:fillRef>
+          <a:effectRef idx="0">
+            <a:schemeClr val="accent1"/>
+          </a:effectRef>
+          <a:fontRef idx="minor">
+            <a:schemeClr val="tx1"/>
+          </a:fontRef>
+        </p:style>
+      </p:cxnSp>
       <p:sp>
         <p:nvSpPr>
-          <p:cNvPr id="42" name="TextBox 41"/>
+          <p:cNvPr id="25" name="TextBox 24"/>
           <p:cNvSpPr txBox="1"/>
           <p:nvPr/>
         </p:nvSpPr>
         <p:spPr>
           <a:xfrm>
-            <a:off x="254000" y="9560000"/>
-            <a:ext cx="6350000" cy="300000"/>
+            <a:off x="254000" y="7910000"/>
+            <a:ext cx="1450000" cy="460000"/>
+          </a:xfrm>
+          <a:prstGeom prst="rect">
+            <a:avLst/>
+          </a:prstGeom>
+          <a:noFill/>
+        </p:spPr>
+        <p:txBody>
+          <a:bodyPr wrap="square" anchor="ctr" lIns="0" rIns="0" tIns="0" bIns="0"/>
+          <a:lstStyle/>
+          <a:p>
+            <a:pPr algn="ctr"/>
+            <a:r>
+              <a:rPr sz="850" b="0">
+                <a:solidFill>
+                  <a:srgbClr val="595959"/>
+                </a:solidFill>
+                <a:latin typeface="신세계 민부리 Light(TTF)"/>
+                <a:ea typeface="신세계 민부리 Light(TTF)"/>
+                <a:cs typeface="신세계 민부리 Light(TTF)"/>
+              </a:rPr>
+              <a:t>年 매출</a:t>
+            </a:r>
+          </a:p>
+          <a:p>
+            <a:pPr algn="ctr"/>
+            <a:r>
+              <a:rPr sz="1500" b="1">
+                <a:solidFill>
+                  <a:srgbClr val="002060"/>
+                </a:solidFill>
+                <a:latin typeface="신세계 민부리 Bold(TTF)"/>
+                <a:ea typeface="신세계 민부리 Bold(TTF)"/>
+                <a:cs typeface="신세계 민부리 Bold(TTF)"/>
+              </a:rPr>
+              <a:t>2.6</a:t>
+            </a:r>
+            <a:r>
+              <a:rPr sz="900" b="1">
+                <a:solidFill>
+                  <a:srgbClr val="002060"/>
+                </a:solidFill>
+                <a:latin typeface="신세계 민부리 Bold(TTF)"/>
+                <a:ea typeface="신세계 민부리 Bold(TTF)"/>
+                <a:cs typeface="신세계 민부리 Bold(TTF)"/>
+              </a:rPr>
+              <a:t>조</a:t>
+            </a:r>
+          </a:p>
+          <a:p>
+            <a:pPr algn="ctr"/>
+            <a:r>
+              <a:rPr sz="750" b="0">
+                <a:solidFill>
+                  <a:srgbClr val="595959"/>
+                </a:solidFill>
+                <a:latin typeface="신세계 민부리 Light(TTF)"/>
+                <a:ea typeface="신세계 민부리 Light(TTF)"/>
+                <a:cs typeface="신세계 민부리 Light(TTF)"/>
+              </a:rPr>
+              <a:t>분양매출 12.6조 별도</a:t>
+            </a:r>
+          </a:p>
+        </p:txBody>
+      </p:sp>
+      <p:cxnSp>
+        <p:nvCxnSpPr>
+          <p:cNvPr id="26" name="Connector 25"/>
+          <p:cNvCxnSpPr/>
+          <p:nvPr/>
+        </p:nvCxnSpPr>
+        <p:spPr>
+          <a:xfrm>
+            <a:off x="254000" y="8410000"/>
+            <a:ext cx="1450000" cy="0"/>
+          </a:xfrm>
+          <a:prstGeom prst="line">
+            <a:avLst/>
+          </a:prstGeom>
+          <a:ln w="19050">
+            <a:solidFill>
+              <a:srgbClr val="002060"/>
+            </a:solidFill>
+          </a:ln>
+        </p:spPr>
+        <p:style>
+          <a:lnRef idx="2">
+            <a:schemeClr val="accent1"/>
+          </a:lnRef>
+          <a:fillRef idx="0">
+            <a:schemeClr val="accent1"/>
+          </a:fillRef>
+          <a:effectRef idx="0">
+            <a:schemeClr val="accent1"/>
+          </a:effectRef>
+          <a:fontRef idx="minor">
+            <a:schemeClr val="tx1"/>
+          </a:fontRef>
+        </p:style>
+      </p:cxnSp>
+      <p:sp>
+        <p:nvSpPr>
+          <p:cNvPr id="27" name="TextBox 26"/>
+          <p:cNvSpPr txBox="1"/>
+          <p:nvPr/>
+        </p:nvSpPr>
+        <p:spPr>
+          <a:xfrm>
+            <a:off x="254000" y="8430000"/>
+            <a:ext cx="1450000" cy="460000"/>
+          </a:xfrm>
+          <a:prstGeom prst="rect">
+            <a:avLst/>
+          </a:prstGeom>
+          <a:noFill/>
+        </p:spPr>
+        <p:txBody>
+          <a:bodyPr wrap="square" anchor="ctr" lIns="0" rIns="0" tIns="0" bIns="0"/>
+          <a:lstStyle/>
+          <a:p>
+            <a:pPr algn="ctr"/>
+            <a:r>
+              <a:rPr sz="850" b="0">
+                <a:solidFill>
+                  <a:srgbClr val="595959"/>
+                </a:solidFill>
+                <a:latin typeface="신세계 민부리 Light(TTF)"/>
+                <a:ea typeface="신세계 민부리 Light(TTF)"/>
+                <a:cs typeface="신세계 민부리 Light(TTF)"/>
+              </a:rPr>
+              <a:t>年 현금흐름</a:t>
+            </a:r>
+          </a:p>
+          <a:p>
+            <a:pPr algn="ctr"/>
+            <a:r>
+              <a:rPr sz="1500" b="1">
+                <a:solidFill>
+                  <a:srgbClr val="002060"/>
+                </a:solidFill>
+                <a:latin typeface="신세계 민부리 Bold(TTF)"/>
+                <a:ea typeface="신세계 민부리 Bold(TTF)"/>
+                <a:cs typeface="신세계 민부리 Bold(TTF)"/>
+              </a:rPr>
+              <a:t>1.0</a:t>
+            </a:r>
+            <a:r>
+              <a:rPr sz="900" b="1">
+                <a:solidFill>
+                  <a:srgbClr val="002060"/>
+                </a:solidFill>
+                <a:latin typeface="신세계 민부리 Bold(TTF)"/>
+                <a:ea typeface="신세계 민부리 Bold(TTF)"/>
+                <a:cs typeface="신세계 민부리 Bold(TTF)"/>
+              </a:rPr>
+              <a:t>조</a:t>
+            </a:r>
+          </a:p>
+          <a:p>
+            <a:pPr algn="ctr"/>
+            <a:r>
+              <a:rPr sz="750" b="0">
+                <a:solidFill>
+                  <a:srgbClr val="595959"/>
+                </a:solidFill>
+                <a:latin typeface="신세계 민부리 Light(TTF)"/>
+                <a:ea typeface="신세계 민부리 Light(TTF)"/>
+                <a:cs typeface="신세계 민부리 Light(TTF)"/>
+              </a:rPr>
+              <a:t>운영이익 + 감가상각</a:t>
+            </a:r>
+          </a:p>
+        </p:txBody>
+      </p:sp>
+      <p:graphicFrame>
+        <p:nvGraphicFramePr>
+          <p:cNvPr id="28" name="Table 27"/>
+          <p:cNvGraphicFramePr>
+            <a:graphicFrameLocks noGrp="1"/>
+          </p:cNvGraphicFramePr>
+          <p:nvPr/>
+        </p:nvGraphicFramePr>
+        <p:xfrm>
+          <a:off x="1854000" y="7890000"/>
+          <a:ext cx="4750000" cy="1020000"/>
+        </p:xfrm>
+        <a:graphic>
+          <a:graphicData uri="http://schemas.openxmlformats.org/drawingml/2006/table">
+            <a:tbl>
+              <a:tblPr firstRow="0" bandRow="0">
+                <a:tableStyleId>{2D5ABB26-0587-4C30-8999-92F81FD0307C}</a:tableStyleId>
+              </a:tblPr>
+              <a:tblGrid>
+                <a:gridCol w="670000"/>
+                <a:gridCol w="510000"/>
+                <a:gridCol w="510000"/>
+                <a:gridCol w="510000"/>
+                <a:gridCol w="510000"/>
+                <a:gridCol w="510000"/>
+                <a:gridCol w="510000"/>
+                <a:gridCol w="510000"/>
+                <a:gridCol w="510000"/>
+              </a:tblGrid>
+              <a:tr h="255000">
+                <a:tc>
+                  <a:txBody>
+                    <a:bodyPr wrap="square"/>
+                    <a:lstStyle/>
+                    <a:p>
+                      <a:pPr algn="ctr"/>
+                      <a:r>
+                        <a:rPr sz="850" b="1">
+                          <a:solidFill>
+                            <a:srgbClr val="595959"/>
+                          </a:solidFill>
+                          <a:latin typeface="신세계 민부리 Bold(TTF)"/>
+                          <a:ea typeface="신세계 민부리 Bold(TTF)"/>
+                          <a:cs typeface="신세계 민부리 Bold(TTF)"/>
+                        </a:rPr>
+                        <a:t>구분</a:t>
+                      </a:r>
+                    </a:p>
+                  </a:txBody>
+                  <a:tcPr marL="40000" marR="40000" marT="0" marB="0" anchor="ctr">
+                    <a:lnL w="0">
+                      <a:noFill/>
+                    </a:lnL>
+                    <a:lnR w="0">
+                      <a:noFill/>
+                    </a:lnR>
+                    <a:lnT w="15875">
+                      <a:solidFill>
+                        <a:srgbClr val="002060"/>
+                      </a:solidFill>
+                    </a:lnT>
+                    <a:lnB w="9525">
+                      <a:solidFill>
+                        <a:srgbClr val="D9D9D9"/>
+                      </a:solidFill>
+                    </a:lnB>
+                    <a:noFill/>
+                  </a:tcPr>
+                </a:tc>
+                <a:tc>
+                  <a:txBody>
+                    <a:bodyPr wrap="square"/>
+                    <a:lstStyle/>
+                    <a:p>
+                      <a:pPr algn="ctr"/>
+                      <a:r>
+                        <a:rPr sz="850" b="1">
+                          <a:solidFill>
+                            <a:srgbClr val="000000"/>
+                          </a:solidFill>
+                          <a:latin typeface="신세계 민부리 Bold(TTF)"/>
+                          <a:ea typeface="신세계 민부리 Bold(TTF)"/>
+                          <a:cs typeface="신세계 민부리 Bold(TTF)"/>
+                        </a:rPr>
+                        <a:t>논현</a:t>
+                      </a:r>
+                    </a:p>
+                  </a:txBody>
+                  <a:tcPr marL="40000" marR="40000" marT="0" marB="0" anchor="ctr">
+                    <a:lnL w="0">
+                      <a:noFill/>
+                    </a:lnL>
+                    <a:lnR w="0">
+                      <a:noFill/>
+                    </a:lnR>
+                    <a:lnT w="15875">
+                      <a:solidFill>
+                        <a:srgbClr val="002060"/>
+                      </a:solidFill>
+                    </a:lnT>
+                    <a:lnB w="9525">
+                      <a:solidFill>
+                        <a:srgbClr val="D9D9D9"/>
+                      </a:solidFill>
+                    </a:lnB>
+                    <a:noFill/>
+                  </a:tcPr>
+                </a:tc>
+                <a:tc>
+                  <a:txBody>
+                    <a:bodyPr wrap="square"/>
+                    <a:lstStyle/>
+                    <a:p>
+                      <a:pPr algn="ctr"/>
+                      <a:r>
+                        <a:rPr sz="850" b="1">
+                          <a:solidFill>
+                            <a:srgbClr val="000000"/>
+                          </a:solidFill>
+                          <a:latin typeface="신세계 민부리 Bold(TTF)"/>
+                          <a:ea typeface="신세계 민부리 Bold(TTF)"/>
+                          <a:cs typeface="신세계 민부리 Bold(TTF)"/>
+                        </a:rPr>
+                        <a:t>영랑호</a:t>
+                      </a:r>
+                    </a:p>
+                  </a:txBody>
+                  <a:tcPr marL="40000" marR="40000" marT="0" marB="0" anchor="ctr">
+                    <a:lnL w="0">
+                      <a:noFill/>
+                    </a:lnL>
+                    <a:lnR w="0">
+                      <a:noFill/>
+                    </a:lnR>
+                    <a:lnT w="15875">
+                      <a:solidFill>
+                        <a:srgbClr val="002060"/>
+                      </a:solidFill>
+                    </a:lnT>
+                    <a:lnB w="9525">
+                      <a:solidFill>
+                        <a:srgbClr val="D9D9D9"/>
+                      </a:solidFill>
+                    </a:lnB>
+                    <a:noFill/>
+                  </a:tcPr>
+                </a:tc>
+                <a:tc>
+                  <a:txBody>
+                    <a:bodyPr wrap="square"/>
+                    <a:lstStyle/>
+                    <a:p>
+                      <a:pPr algn="ctr"/>
+                      <a:r>
+                        <a:rPr sz="850" b="1">
+                          <a:solidFill>
+                            <a:srgbClr val="000000"/>
+                          </a:solidFill>
+                          <a:latin typeface="신세계 민부리 Bold(TTF)"/>
+                          <a:ea typeface="신세계 민부리 Bold(TTF)"/>
+                          <a:cs typeface="신세계 민부리 Bold(TTF)"/>
+                        </a:rPr>
+                        <a:t>송도</a:t>
+                      </a:r>
+                    </a:p>
+                  </a:txBody>
+                  <a:tcPr marL="40000" marR="40000" marT="0" marB="0" anchor="ctr">
+                    <a:lnL w="0">
+                      <a:noFill/>
+                    </a:lnL>
+                    <a:lnR w="0">
+                      <a:noFill/>
+                    </a:lnR>
+                    <a:lnT w="15875">
+                      <a:solidFill>
+                        <a:srgbClr val="002060"/>
+                      </a:solidFill>
+                    </a:lnT>
+                    <a:lnB w="9525">
+                      <a:solidFill>
+                        <a:srgbClr val="D9D9D9"/>
+                      </a:solidFill>
+                    </a:lnB>
+                    <a:noFill/>
+                  </a:tcPr>
+                </a:tc>
+                <a:tc>
+                  <a:txBody>
+                    <a:bodyPr wrap="square"/>
+                    <a:lstStyle/>
+                    <a:p>
+                      <a:pPr algn="ctr"/>
+                      <a:r>
+                        <a:rPr sz="850" b="1">
+                          <a:solidFill>
+                            <a:srgbClr val="000000"/>
+                          </a:solidFill>
+                          <a:latin typeface="신세계 민부리 Bold(TTF)"/>
+                          <a:ea typeface="신세계 민부리 Bold(TTF)"/>
+                          <a:cs typeface="신세계 민부리 Bold(TTF)"/>
+                        </a:rPr>
+                        <a:t>수서</a:t>
+                      </a:r>
+                    </a:p>
+                  </a:txBody>
+                  <a:tcPr marL="40000" marR="40000" marT="0" marB="0" anchor="ctr">
+                    <a:lnL w="0">
+                      <a:noFill/>
+                    </a:lnL>
+                    <a:lnR w="0">
+                      <a:noFill/>
+                    </a:lnR>
+                    <a:lnT w="15875">
+                      <a:solidFill>
+                        <a:srgbClr val="002060"/>
+                      </a:solidFill>
+                    </a:lnT>
+                    <a:lnB w="9525">
+                      <a:solidFill>
+                        <a:srgbClr val="D9D9D9"/>
+                      </a:solidFill>
+                    </a:lnB>
+                    <a:noFill/>
+                  </a:tcPr>
+                </a:tc>
+                <a:tc>
+                  <a:txBody>
+                    <a:bodyPr wrap="square"/>
+                    <a:lstStyle/>
+                    <a:p>
+                      <a:pPr algn="ctr"/>
+                      <a:r>
+                        <a:rPr sz="850" b="1">
+                          <a:solidFill>
+                            <a:srgbClr val="000000"/>
+                          </a:solidFill>
+                          <a:latin typeface="신세계 민부리 Bold(TTF)"/>
+                          <a:ea typeface="신세계 민부리 Bold(TTF)"/>
+                          <a:cs typeface="신세계 민부리 Bold(TTF)"/>
+                        </a:rPr>
+                        <a:t>센텀</a:t>
+                      </a:r>
+                    </a:p>
+                  </a:txBody>
+                  <a:tcPr marL="40000" marR="40000" marT="0" marB="0" anchor="ctr">
+                    <a:lnL w="0">
+                      <a:noFill/>
+                    </a:lnL>
+                    <a:lnR w="0">
+                      <a:noFill/>
+                    </a:lnR>
+                    <a:lnT w="15875">
+                      <a:solidFill>
+                        <a:srgbClr val="002060"/>
+                      </a:solidFill>
+                    </a:lnT>
+                    <a:lnB w="9525">
+                      <a:solidFill>
+                        <a:srgbClr val="D9D9D9"/>
+                      </a:solidFill>
+                    </a:lnB>
+                    <a:noFill/>
+                  </a:tcPr>
+                </a:tc>
+                <a:tc>
+                  <a:txBody>
+                    <a:bodyPr wrap="square"/>
+                    <a:lstStyle/>
+                    <a:p>
+                      <a:pPr algn="ctr"/>
+                      <a:r>
+                        <a:rPr sz="850" b="1">
+                          <a:solidFill>
+                            <a:srgbClr val="000000"/>
+                          </a:solidFill>
+                          <a:latin typeface="신세계 민부리 Bold(TTF)"/>
+                          <a:ea typeface="신세계 민부리 Bold(TTF)"/>
+                          <a:cs typeface="신세계 민부리 Bold(TTF)"/>
+                        </a:rPr>
+                        <a:t>울산</a:t>
+                      </a:r>
+                    </a:p>
+                  </a:txBody>
+                  <a:tcPr marL="40000" marR="40000" marT="0" marB="0" anchor="ctr">
+                    <a:lnL w="0">
+                      <a:noFill/>
+                    </a:lnL>
+                    <a:lnR w="0">
+                      <a:noFill/>
+                    </a:lnR>
+                    <a:lnT w="15875">
+                      <a:solidFill>
+                        <a:srgbClr val="002060"/>
+                      </a:solidFill>
+                    </a:lnT>
+                    <a:lnB w="9525">
+                      <a:solidFill>
+                        <a:srgbClr val="D9D9D9"/>
+                      </a:solidFill>
+                    </a:lnB>
+                    <a:noFill/>
+                  </a:tcPr>
+                </a:tc>
+                <a:tc>
+                  <a:txBody>
+                    <a:bodyPr wrap="square"/>
+                    <a:lstStyle/>
+                    <a:p>
+                      <a:pPr algn="ctr"/>
+                      <a:r>
+                        <a:rPr sz="850" b="1">
+                          <a:solidFill>
+                            <a:srgbClr val="000000"/>
+                          </a:solidFill>
+                          <a:latin typeface="신세계 민부리 Bold(TTF)"/>
+                          <a:ea typeface="신세계 민부리 Bold(TTF)"/>
+                          <a:cs typeface="신세계 민부리 Bold(TTF)"/>
+                        </a:rPr>
+                        <a:t>광주</a:t>
+                      </a:r>
+                    </a:p>
+                  </a:txBody>
+                  <a:tcPr marL="40000" marR="40000" marT="0" marB="0" anchor="ctr">
+                    <a:lnL w="0">
+                      <a:noFill/>
+                    </a:lnL>
+                    <a:lnR w="0">
+                      <a:noFill/>
+                    </a:lnR>
+                    <a:lnT w="15875">
+                      <a:solidFill>
+                        <a:srgbClr val="002060"/>
+                      </a:solidFill>
+                    </a:lnT>
+                    <a:lnB w="9525">
+                      <a:solidFill>
+                        <a:srgbClr val="D9D9D9"/>
+                      </a:solidFill>
+                    </a:lnB>
+                    <a:noFill/>
+                  </a:tcPr>
+                </a:tc>
+                <a:tc>
+                  <a:txBody>
+                    <a:bodyPr wrap="square"/>
+                    <a:lstStyle/>
+                    <a:p>
+                      <a:pPr algn="ctr"/>
+                      <a:r>
+                        <a:rPr sz="850" b="1">
+                          <a:solidFill>
+                            <a:srgbClr val="002060"/>
+                          </a:solidFill>
+                          <a:latin typeface="신세계 민부리 Bold(TTF)"/>
+                          <a:ea typeface="신세계 민부리 Bold(TTF)"/>
+                          <a:cs typeface="신세계 민부리 Bold(TTF)"/>
+                        </a:rPr>
+                        <a:t>반포</a:t>
+                      </a:r>
+                    </a:p>
+                  </a:txBody>
+                  <a:tcPr marL="40000" marR="40000" marT="0" marB="0" anchor="ctr">
+                    <a:lnL w="0">
+                      <a:noFill/>
+                    </a:lnL>
+                    <a:lnR w="0">
+                      <a:noFill/>
+                    </a:lnR>
+                    <a:lnT w="15875">
+                      <a:solidFill>
+                        <a:srgbClr val="002060"/>
+                      </a:solidFill>
+                    </a:lnT>
+                    <a:lnB w="9525">
+                      <a:solidFill>
+                        <a:srgbClr val="D9D9D9"/>
+                      </a:solidFill>
+                    </a:lnB>
+                    <a:solidFill>
+                      <a:srgbClr val="EAF2FB"/>
+                    </a:solidFill>
+                  </a:tcPr>
+                </a:tc>
+              </a:tr>
+              <a:tr h="255000">
+                <a:tc>
+                  <a:txBody>
+                    <a:bodyPr wrap="square"/>
+                    <a:lstStyle/>
+                    <a:p>
+                      <a:pPr algn="ctr"/>
+                      <a:r>
+                        <a:rPr sz="850" b="1">
+                          <a:solidFill>
+                            <a:srgbClr val="595959"/>
+                          </a:solidFill>
+                          <a:latin typeface="신세계 민부리 Bold(TTF)"/>
+                          <a:ea typeface="신세계 민부리 Bold(TTF)"/>
+                          <a:cs typeface="신세계 민부리 Bold(TTF)"/>
+                        </a:rPr>
+                        <a:t>IRR</a:t>
+                      </a:r>
+                    </a:p>
+                  </a:txBody>
+                  <a:tcPr marL="40000" marR="40000" marT="0" marB="0" anchor="ctr">
+                    <a:lnL w="0">
+                      <a:noFill/>
+                    </a:lnL>
+                    <a:lnR w="0">
+                      <a:noFill/>
+                    </a:lnR>
+                    <a:lnT w="6350">
+                      <a:solidFill>
+                        <a:srgbClr val="D9D9D9"/>
+                      </a:solidFill>
+                    </a:lnT>
+                    <a:lnB w="6350">
+                      <a:solidFill>
+                        <a:srgbClr val="D9D9D9"/>
+                      </a:solidFill>
+                    </a:lnB>
+                    <a:noFill/>
+                  </a:tcPr>
+                </a:tc>
+                <a:tc>
+                  <a:txBody>
+                    <a:bodyPr wrap="square"/>
+                    <a:lstStyle/>
+                    <a:p>
+                      <a:pPr algn="ctr"/>
+                      <a:r>
+                        <a:rPr sz="850" b="0">
+                          <a:solidFill>
+                            <a:srgbClr val="000000"/>
+                          </a:solidFill>
+                          <a:latin typeface="신세계 민부리 Light(TTF)"/>
+                          <a:ea typeface="신세계 민부리 Light(TTF)"/>
+                          <a:cs typeface="신세계 민부리 Light(TTF)"/>
+                        </a:rPr>
+                        <a:t>10.0%</a:t>
+                      </a:r>
+                    </a:p>
+                  </a:txBody>
+                  <a:tcPr marL="40000" marR="40000" marT="0" marB="0" anchor="ctr">
+                    <a:lnL w="0">
+                      <a:noFill/>
+                    </a:lnL>
+                    <a:lnR w="0">
+                      <a:noFill/>
+                    </a:lnR>
+                    <a:lnT w="6350">
+                      <a:solidFill>
+                        <a:srgbClr val="D9D9D9"/>
+                      </a:solidFill>
+                    </a:lnT>
+                    <a:lnB w="6350">
+                      <a:solidFill>
+                        <a:srgbClr val="D9D9D9"/>
+                      </a:solidFill>
+                    </a:lnB>
+                    <a:noFill/>
+                  </a:tcPr>
+                </a:tc>
+                <a:tc>
+                  <a:txBody>
+                    <a:bodyPr wrap="square"/>
+                    <a:lstStyle/>
+                    <a:p>
+                      <a:pPr algn="ctr"/>
+                      <a:r>
+                        <a:rPr sz="850" b="0">
+                          <a:solidFill>
+                            <a:srgbClr val="000000"/>
+                          </a:solidFill>
+                          <a:latin typeface="신세계 민부리 Light(TTF)"/>
+                          <a:ea typeface="신세계 민부리 Light(TTF)"/>
+                          <a:cs typeface="신세계 민부리 Light(TTF)"/>
+                        </a:rPr>
+                        <a:t>9.0%</a:t>
+                      </a:r>
+                    </a:p>
+                  </a:txBody>
+                  <a:tcPr marL="40000" marR="40000" marT="0" marB="0" anchor="ctr">
+                    <a:lnL w="0">
+                      <a:noFill/>
+                    </a:lnL>
+                    <a:lnR w="0">
+                      <a:noFill/>
+                    </a:lnR>
+                    <a:lnT w="6350">
+                      <a:solidFill>
+                        <a:srgbClr val="D9D9D9"/>
+                      </a:solidFill>
+                    </a:lnT>
+                    <a:lnB w="6350">
+                      <a:solidFill>
+                        <a:srgbClr val="D9D9D9"/>
+                      </a:solidFill>
+                    </a:lnB>
+                    <a:noFill/>
+                  </a:tcPr>
+                </a:tc>
+                <a:tc>
+                  <a:txBody>
+                    <a:bodyPr wrap="square"/>
+                    <a:lstStyle/>
+                    <a:p>
+                      <a:pPr algn="ctr"/>
+                      <a:r>
+                        <a:rPr sz="850" b="1">
+                          <a:solidFill>
+                            <a:srgbClr val="C00000"/>
+                          </a:solidFill>
+                          <a:latin typeface="신세계 민부리 Bold(TTF)"/>
+                          <a:ea typeface="신세계 민부리 Bold(TTF)"/>
+                          <a:cs typeface="신세계 민부리 Bold(TTF)"/>
+                        </a:rPr>
+                        <a:t>6.6%</a:t>
+                      </a:r>
+                    </a:p>
+                  </a:txBody>
+                  <a:tcPr marL="40000" marR="40000" marT="0" marB="0" anchor="ctr">
+                    <a:lnL w="0">
+                      <a:noFill/>
+                    </a:lnL>
+                    <a:lnR w="0">
+                      <a:noFill/>
+                    </a:lnR>
+                    <a:lnT w="6350">
+                      <a:solidFill>
+                        <a:srgbClr val="D9D9D9"/>
+                      </a:solidFill>
+                    </a:lnT>
+                    <a:lnB w="6350">
+                      <a:solidFill>
+                        <a:srgbClr val="D9D9D9"/>
+                      </a:solidFill>
+                    </a:lnB>
+                    <a:noFill/>
+                  </a:tcPr>
+                </a:tc>
+                <a:tc>
+                  <a:txBody>
+                    <a:bodyPr wrap="square"/>
+                    <a:lstStyle/>
+                    <a:p>
+                      <a:pPr algn="ctr"/>
+                      <a:r>
+                        <a:rPr sz="850" b="0">
+                          <a:solidFill>
+                            <a:srgbClr val="000000"/>
+                          </a:solidFill>
+                          <a:latin typeface="신세계 민부리 Light(TTF)"/>
+                          <a:ea typeface="신세계 민부리 Light(TTF)"/>
+                          <a:cs typeface="신세계 민부리 Light(TTF)"/>
+                        </a:rPr>
+                        <a:t>13.2%</a:t>
+                      </a:r>
+                    </a:p>
+                  </a:txBody>
+                  <a:tcPr marL="40000" marR="40000" marT="0" marB="0" anchor="ctr">
+                    <a:lnL w="0">
+                      <a:noFill/>
+                    </a:lnL>
+                    <a:lnR w="0">
+                      <a:noFill/>
+                    </a:lnR>
+                    <a:lnT w="6350">
+                      <a:solidFill>
+                        <a:srgbClr val="D9D9D9"/>
+                      </a:solidFill>
+                    </a:lnT>
+                    <a:lnB w="6350">
+                      <a:solidFill>
+                        <a:srgbClr val="D9D9D9"/>
+                      </a:solidFill>
+                    </a:lnB>
+                    <a:noFill/>
+                  </a:tcPr>
+                </a:tc>
+                <a:tc>
+                  <a:txBody>
+                    <a:bodyPr wrap="square"/>
+                    <a:lstStyle/>
+                    <a:p>
+                      <a:pPr algn="ctr"/>
+                      <a:r>
+                        <a:rPr sz="850" b="1">
+                          <a:solidFill>
+                            <a:srgbClr val="C00000"/>
+                          </a:solidFill>
+                          <a:latin typeface="신세계 민부리 Bold(TTF)"/>
+                          <a:ea typeface="신세계 민부리 Bold(TTF)"/>
+                          <a:cs typeface="신세계 민부리 Bold(TTF)"/>
+                        </a:rPr>
+                        <a:t>4.5%¹⁾</a:t>
+                      </a:r>
+                    </a:p>
+                  </a:txBody>
+                  <a:tcPr marL="40000" marR="40000" marT="0" marB="0" anchor="ctr">
+                    <a:lnL w="0">
+                      <a:noFill/>
+                    </a:lnL>
+                    <a:lnR w="0">
+                      <a:noFill/>
+                    </a:lnR>
+                    <a:lnT w="6350">
+                      <a:solidFill>
+                        <a:srgbClr val="D9D9D9"/>
+                      </a:solidFill>
+                    </a:lnT>
+                    <a:lnB w="6350">
+                      <a:solidFill>
+                        <a:srgbClr val="D9D9D9"/>
+                      </a:solidFill>
+                    </a:lnB>
+                    <a:noFill/>
+                  </a:tcPr>
+                </a:tc>
+                <a:tc>
+                  <a:txBody>
+                    <a:bodyPr wrap="square"/>
+                    <a:lstStyle/>
+                    <a:p>
+                      <a:pPr algn="ctr"/>
+                      <a:r>
+                        <a:rPr sz="850" b="0">
+                          <a:solidFill>
+                            <a:srgbClr val="000000"/>
+                          </a:solidFill>
+                          <a:latin typeface="신세계 민부리 Light(TTF)"/>
+                          <a:ea typeface="신세계 민부리 Light(TTF)"/>
+                          <a:cs typeface="신세계 민부리 Light(TTF)"/>
+                        </a:rPr>
+                        <a:t>12.7%</a:t>
+                      </a:r>
+                    </a:p>
+                  </a:txBody>
+                  <a:tcPr marL="40000" marR="40000" marT="0" marB="0" anchor="ctr">
+                    <a:lnL w="0">
+                      <a:noFill/>
+                    </a:lnL>
+                    <a:lnR w="0">
+                      <a:noFill/>
+                    </a:lnR>
+                    <a:lnT w="6350">
+                      <a:solidFill>
+                        <a:srgbClr val="D9D9D9"/>
+                      </a:solidFill>
+                    </a:lnT>
+                    <a:lnB w="6350">
+                      <a:solidFill>
+                        <a:srgbClr val="D9D9D9"/>
+                      </a:solidFill>
+                    </a:lnB>
+                    <a:noFill/>
+                  </a:tcPr>
+                </a:tc>
+                <a:tc>
+                  <a:txBody>
+                    <a:bodyPr wrap="square"/>
+                    <a:lstStyle/>
+                    <a:p>
+                      <a:pPr algn="ctr"/>
+                      <a:r>
+                        <a:rPr sz="850" b="0">
+                          <a:solidFill>
+                            <a:srgbClr val="000000"/>
+                          </a:solidFill>
+                          <a:latin typeface="신세계 민부리 Light(TTF)"/>
+                          <a:ea typeface="신세계 민부리 Light(TTF)"/>
+                          <a:cs typeface="신세계 민부리 Light(TTF)"/>
+                        </a:rPr>
+                        <a:t>10.5%</a:t>
+                      </a:r>
+                    </a:p>
+                  </a:txBody>
+                  <a:tcPr marL="40000" marR="40000" marT="0" marB="0" anchor="ctr">
+                    <a:lnL w="0">
+                      <a:noFill/>
+                    </a:lnL>
+                    <a:lnR w="0">
+                      <a:noFill/>
+                    </a:lnR>
+                    <a:lnT w="6350">
+                      <a:solidFill>
+                        <a:srgbClr val="D9D9D9"/>
+                      </a:solidFill>
+                    </a:lnT>
+                    <a:lnB w="6350">
+                      <a:solidFill>
+                        <a:srgbClr val="D9D9D9"/>
+                      </a:solidFill>
+                    </a:lnB>
+                    <a:noFill/>
+                  </a:tcPr>
+                </a:tc>
+                <a:tc>
+                  <a:txBody>
+                    <a:bodyPr wrap="square"/>
+                    <a:lstStyle/>
+                    <a:p>
+                      <a:pPr algn="ctr"/>
+                      <a:r>
+                        <a:rPr sz="850" b="1">
+                          <a:solidFill>
+                            <a:srgbClr val="002060"/>
+                          </a:solidFill>
+                          <a:latin typeface="신세계 민부리 Bold(TTF)"/>
+                          <a:ea typeface="신세계 민부리 Bold(TTF)"/>
+                          <a:cs typeface="신세계 민부리 Bold(TTF)"/>
+                        </a:rPr>
+                        <a:t>7.7%</a:t>
+                      </a:r>
+                    </a:p>
+                  </a:txBody>
+                  <a:tcPr marL="40000" marR="40000" marT="0" marB="0" anchor="ctr">
+                    <a:lnL w="0">
+                      <a:noFill/>
+                    </a:lnL>
+                    <a:lnR w="0">
+                      <a:noFill/>
+                    </a:lnR>
+                    <a:lnT w="6350">
+                      <a:solidFill>
+                        <a:srgbClr val="D9D9D9"/>
+                      </a:solidFill>
+                    </a:lnT>
+                    <a:lnB w="6350">
+                      <a:solidFill>
+                        <a:srgbClr val="D9D9D9"/>
+                      </a:solidFill>
+                    </a:lnB>
+                    <a:solidFill>
+                      <a:srgbClr val="EAF2FB"/>
+                    </a:solidFill>
+                  </a:tcPr>
+                </a:tc>
+              </a:tr>
+              <a:tr h="255000">
+                <a:tc>
+                  <a:txBody>
+                    <a:bodyPr wrap="square"/>
+                    <a:lstStyle/>
+                    <a:p>
+                      <a:pPr algn="ctr"/>
+                      <a:r>
+                        <a:rPr sz="850" b="1">
+                          <a:solidFill>
+                            <a:srgbClr val="595959"/>
+                          </a:solidFill>
+                          <a:latin typeface="신세계 민부리 Bold(TTF)"/>
+                          <a:ea typeface="신세계 민부리 Bold(TTF)"/>
+                          <a:cs typeface="신세계 민부리 Bold(TTF)"/>
+                        </a:rPr>
+                        <a:t>투자회수</a:t>
+                      </a:r>
+                    </a:p>
+                  </a:txBody>
+                  <a:tcPr marL="40000" marR="40000" marT="0" marB="0" anchor="ctr">
+                    <a:lnL w="0">
+                      <a:noFill/>
+                    </a:lnL>
+                    <a:lnR w="0">
+                      <a:noFill/>
+                    </a:lnR>
+                    <a:lnT w="6350">
+                      <a:solidFill>
+                        <a:srgbClr val="D9D9D9"/>
+                      </a:solidFill>
+                    </a:lnT>
+                    <a:lnB w="6350">
+                      <a:solidFill>
+                        <a:srgbClr val="D9D9D9"/>
+                      </a:solidFill>
+                    </a:lnB>
+                    <a:noFill/>
+                  </a:tcPr>
+                </a:tc>
+                <a:tc>
+                  <a:txBody>
+                    <a:bodyPr wrap="square"/>
+                    <a:lstStyle/>
+                    <a:p>
+                      <a:pPr algn="ctr"/>
+                      <a:r>
+                        <a:rPr sz="850" b="0">
+                          <a:solidFill>
+                            <a:srgbClr val="000000"/>
+                          </a:solidFill>
+                          <a:latin typeface="신세계 민부리 Light(TTF)"/>
+                          <a:ea typeface="신세계 민부리 Light(TTF)"/>
+                          <a:cs typeface="신세계 민부리 Light(TTF)"/>
+                        </a:rPr>
+                        <a:t>3년차</a:t>
+                      </a:r>
+                    </a:p>
+                  </a:txBody>
+                  <a:tcPr marL="40000" marR="40000" marT="0" marB="0" anchor="ctr">
+                    <a:lnL w="0">
+                      <a:noFill/>
+                    </a:lnL>
+                    <a:lnR w="0">
+                      <a:noFill/>
+                    </a:lnR>
+                    <a:lnT w="6350">
+                      <a:solidFill>
+                        <a:srgbClr val="D9D9D9"/>
+                      </a:solidFill>
+                    </a:lnT>
+                    <a:lnB w="6350">
+                      <a:solidFill>
+                        <a:srgbClr val="D9D9D9"/>
+                      </a:solidFill>
+                    </a:lnB>
+                    <a:noFill/>
+                  </a:tcPr>
+                </a:tc>
+                <a:tc>
+                  <a:txBody>
+                    <a:bodyPr wrap="square"/>
+                    <a:lstStyle/>
+                    <a:p>
+                      <a:pPr algn="ctr"/>
+                      <a:r>
+                        <a:rPr sz="850" b="0">
+                          <a:solidFill>
+                            <a:srgbClr val="000000"/>
+                          </a:solidFill>
+                          <a:latin typeface="신세계 민부리 Light(TTF)"/>
+                          <a:ea typeface="신세계 민부리 Light(TTF)"/>
+                          <a:cs typeface="신세계 민부리 Light(TTF)"/>
+                        </a:rPr>
+                        <a:t>2년차</a:t>
+                      </a:r>
+                    </a:p>
+                  </a:txBody>
+                  <a:tcPr marL="40000" marR="40000" marT="0" marB="0" anchor="ctr">
+                    <a:lnL w="0">
+                      <a:noFill/>
+                    </a:lnL>
+                    <a:lnR w="0">
+                      <a:noFill/>
+                    </a:lnR>
+                    <a:lnT w="6350">
+                      <a:solidFill>
+                        <a:srgbClr val="D9D9D9"/>
+                      </a:solidFill>
+                    </a:lnT>
+                    <a:lnB w="6350">
+                      <a:solidFill>
+                        <a:srgbClr val="D9D9D9"/>
+                      </a:solidFill>
+                    </a:lnB>
+                    <a:noFill/>
+                  </a:tcPr>
+                </a:tc>
+                <a:tc>
+                  <a:txBody>
+                    <a:bodyPr wrap="square"/>
+                    <a:lstStyle/>
+                    <a:p>
+                      <a:pPr algn="ctr"/>
+                      <a:r>
+                        <a:rPr sz="850" b="1">
+                          <a:solidFill>
+                            <a:srgbClr val="C00000"/>
+                          </a:solidFill>
+                          <a:latin typeface="신세계 민부리 Bold(TTF)"/>
+                          <a:ea typeface="신세계 민부리 Bold(TTF)"/>
+                          <a:cs typeface="신세계 민부리 Bold(TTF)"/>
+                        </a:rPr>
+                        <a:t>10년차</a:t>
+                      </a:r>
+                    </a:p>
+                  </a:txBody>
+                  <a:tcPr marL="40000" marR="40000" marT="0" marB="0" anchor="ctr">
+                    <a:lnL w="0">
+                      <a:noFill/>
+                    </a:lnL>
+                    <a:lnR w="0">
+                      <a:noFill/>
+                    </a:lnR>
+                    <a:lnT w="6350">
+                      <a:solidFill>
+                        <a:srgbClr val="D9D9D9"/>
+                      </a:solidFill>
+                    </a:lnT>
+                    <a:lnB w="6350">
+                      <a:solidFill>
+                        <a:srgbClr val="D9D9D9"/>
+                      </a:solidFill>
+                    </a:lnB>
+                    <a:noFill/>
+                  </a:tcPr>
+                </a:tc>
+                <a:tc>
+                  <a:txBody>
+                    <a:bodyPr wrap="square"/>
+                    <a:lstStyle/>
+                    <a:p>
+                      <a:pPr algn="ctr"/>
+                      <a:r>
+                        <a:rPr sz="850" b="0">
+                          <a:solidFill>
+                            <a:srgbClr val="000000"/>
+                          </a:solidFill>
+                          <a:latin typeface="신세계 민부리 Light(TTF)"/>
+                          <a:ea typeface="신세계 민부리 Light(TTF)"/>
+                          <a:cs typeface="신세계 민부리 Light(TTF)"/>
+                        </a:rPr>
+                        <a:t>9년차</a:t>
+                      </a:r>
+                    </a:p>
+                  </a:txBody>
+                  <a:tcPr marL="40000" marR="40000" marT="0" marB="0" anchor="ctr">
+                    <a:lnL w="0">
+                      <a:noFill/>
+                    </a:lnL>
+                    <a:lnR w="0">
+                      <a:noFill/>
+                    </a:lnR>
+                    <a:lnT w="6350">
+                      <a:solidFill>
+                        <a:srgbClr val="D9D9D9"/>
+                      </a:solidFill>
+                    </a:lnT>
+                    <a:lnB w="6350">
+                      <a:solidFill>
+                        <a:srgbClr val="D9D9D9"/>
+                      </a:solidFill>
+                    </a:lnB>
+                    <a:noFill/>
+                  </a:tcPr>
+                </a:tc>
+                <a:tc>
+                  <a:txBody>
+                    <a:bodyPr wrap="square"/>
+                    <a:lstStyle/>
+                    <a:p>
+                      <a:pPr algn="ctr"/>
+                      <a:r>
+                        <a:rPr sz="850" b="0">
+                          <a:solidFill>
+                            <a:srgbClr val="000000"/>
+                          </a:solidFill>
+                          <a:latin typeface="신세계 민부리 Light(TTF)"/>
+                          <a:ea typeface="신세계 민부리 Light(TTF)"/>
+                          <a:cs typeface="신세계 민부리 Light(TTF)"/>
+                        </a:rPr>
+                        <a:t>6년차</a:t>
+                      </a:r>
+                    </a:p>
+                  </a:txBody>
+                  <a:tcPr marL="40000" marR="40000" marT="0" marB="0" anchor="ctr">
+                    <a:lnL w="0">
+                      <a:noFill/>
+                    </a:lnL>
+                    <a:lnR w="0">
+                      <a:noFill/>
+                    </a:lnR>
+                    <a:lnT w="6350">
+                      <a:solidFill>
+                        <a:srgbClr val="D9D9D9"/>
+                      </a:solidFill>
+                    </a:lnT>
+                    <a:lnB w="6350">
+                      <a:solidFill>
+                        <a:srgbClr val="D9D9D9"/>
+                      </a:solidFill>
+                    </a:lnB>
+                    <a:noFill/>
+                  </a:tcPr>
+                </a:tc>
+                <a:tc>
+                  <a:txBody>
+                    <a:bodyPr wrap="square"/>
+                    <a:lstStyle/>
+                    <a:p>
+                      <a:pPr algn="ctr"/>
+                      <a:r>
+                        <a:rPr sz="850" b="0">
+                          <a:solidFill>
+                            <a:srgbClr val="000000"/>
+                          </a:solidFill>
+                          <a:latin typeface="신세계 민부리 Light(TTF)"/>
+                          <a:ea typeface="신세계 민부리 Light(TTF)"/>
+                          <a:cs typeface="신세계 민부리 Light(TTF)"/>
+                        </a:rPr>
+                        <a:t>1년차²⁾</a:t>
+                      </a:r>
+                    </a:p>
+                  </a:txBody>
+                  <a:tcPr marL="40000" marR="40000" marT="0" marB="0" anchor="ctr">
+                    <a:lnL w="0">
+                      <a:noFill/>
+                    </a:lnL>
+                    <a:lnR w="0">
+                      <a:noFill/>
+                    </a:lnR>
+                    <a:lnT w="6350">
+                      <a:solidFill>
+                        <a:srgbClr val="D9D9D9"/>
+                      </a:solidFill>
+                    </a:lnT>
+                    <a:lnB w="6350">
+                      <a:solidFill>
+                        <a:srgbClr val="D9D9D9"/>
+                      </a:solidFill>
+                    </a:lnB>
+                    <a:noFill/>
+                  </a:tcPr>
+                </a:tc>
+                <a:tc>
+                  <a:txBody>
+                    <a:bodyPr wrap="square"/>
+                    <a:lstStyle/>
+                    <a:p>
+                      <a:pPr algn="ctr"/>
+                      <a:r>
+                        <a:rPr sz="850" b="0">
+                          <a:solidFill>
+                            <a:srgbClr val="000000"/>
+                          </a:solidFill>
+                          <a:latin typeface="신세계 민부리 Light(TTF)"/>
+                          <a:ea typeface="신세계 민부리 Light(TTF)"/>
+                          <a:cs typeface="신세계 민부리 Light(TTF)"/>
+                        </a:rPr>
+                        <a:t>11년차</a:t>
+                      </a:r>
+                    </a:p>
+                  </a:txBody>
+                  <a:tcPr marL="40000" marR="40000" marT="0" marB="0" anchor="ctr">
+                    <a:lnL w="0">
+                      <a:noFill/>
+                    </a:lnL>
+                    <a:lnR w="0">
+                      <a:noFill/>
+                    </a:lnR>
+                    <a:lnT w="6350">
+                      <a:solidFill>
+                        <a:srgbClr val="D9D9D9"/>
+                      </a:solidFill>
+                    </a:lnT>
+                    <a:lnB w="6350">
+                      <a:solidFill>
+                        <a:srgbClr val="D9D9D9"/>
+                      </a:solidFill>
+                    </a:lnB>
+                    <a:noFill/>
+                  </a:tcPr>
+                </a:tc>
+                <a:tc>
+                  <a:txBody>
+                    <a:bodyPr wrap="square"/>
+                    <a:lstStyle/>
+                    <a:p>
+                      <a:pPr algn="ctr"/>
+                      <a:r>
+                        <a:rPr sz="850" b="1">
+                          <a:solidFill>
+                            <a:srgbClr val="002060"/>
+                          </a:solidFill>
+                          <a:latin typeface="신세계 민부리 Bold(TTF)"/>
+                          <a:ea typeface="신세계 민부리 Bold(TTF)"/>
+                          <a:cs typeface="신세계 민부리 Bold(TTF)"/>
+                        </a:rPr>
+                        <a:t>7년차</a:t>
+                      </a:r>
+                    </a:p>
+                  </a:txBody>
+                  <a:tcPr marL="40000" marR="40000" marT="0" marB="0" anchor="ctr">
+                    <a:lnL w="0">
+                      <a:noFill/>
+                    </a:lnL>
+                    <a:lnR w="0">
+                      <a:noFill/>
+                    </a:lnR>
+                    <a:lnT w="6350">
+                      <a:solidFill>
+                        <a:srgbClr val="D9D9D9"/>
+                      </a:solidFill>
+                    </a:lnT>
+                    <a:lnB w="6350">
+                      <a:solidFill>
+                        <a:srgbClr val="D9D9D9"/>
+                      </a:solidFill>
+                    </a:lnB>
+                    <a:solidFill>
+                      <a:srgbClr val="EAF2FB"/>
+                    </a:solidFill>
+                  </a:tcPr>
+                </a:tc>
+              </a:tr>
+              <a:tr h="255000">
+                <a:tc>
+                  <a:txBody>
+                    <a:bodyPr wrap="square"/>
+                    <a:lstStyle/>
+                    <a:p>
+                      <a:pPr algn="ctr"/>
+                      <a:r>
+                        <a:rPr sz="850" b="1">
+                          <a:solidFill>
+                            <a:srgbClr val="595959"/>
+                          </a:solidFill>
+                          <a:latin typeface="신세계 민부리 Bold(TTF)"/>
+                          <a:ea typeface="신세계 민부리 Bold(TTF)"/>
+                          <a:cs typeface="신세계 민부리 Bold(TTF)"/>
+                        </a:rPr>
+                        <a:t>年 현금흐름</a:t>
+                      </a:r>
+                    </a:p>
+                  </a:txBody>
+                  <a:tcPr marL="40000" marR="40000" marT="0" marB="0" anchor="ctr">
+                    <a:lnL w="0">
+                      <a:noFill/>
+                    </a:lnL>
+                    <a:lnR w="0">
+                      <a:noFill/>
+                    </a:lnR>
+                    <a:lnT w="6350">
+                      <a:solidFill>
+                        <a:srgbClr val="D9D9D9"/>
+                      </a:solidFill>
+                    </a:lnT>
+                    <a:lnB w="12700">
+                      <a:solidFill>
+                        <a:srgbClr val="002060"/>
+                      </a:solidFill>
+                    </a:lnB>
+                    <a:noFill/>
+                  </a:tcPr>
+                </a:tc>
+                <a:tc>
+                  <a:txBody>
+                    <a:bodyPr wrap="square"/>
+                    <a:lstStyle/>
+                    <a:p>
+                      <a:pPr algn="ctr"/>
+                      <a:r>
+                        <a:rPr sz="850" b="0">
+                          <a:solidFill>
+                            <a:srgbClr val="000000"/>
+                          </a:solidFill>
+                          <a:latin typeface="신세계 민부리 Light(TTF)"/>
+                          <a:ea typeface="신세계 민부리 Light(TTF)"/>
+                          <a:cs typeface="신세계 민부리 Light(TTF)"/>
+                        </a:rPr>
+                        <a:t>60억</a:t>
+                      </a:r>
+                    </a:p>
+                  </a:txBody>
+                  <a:tcPr marL="40000" marR="40000" marT="0" marB="0" anchor="ctr">
+                    <a:lnL w="0">
+                      <a:noFill/>
+                    </a:lnL>
+                    <a:lnR w="0">
+                      <a:noFill/>
+                    </a:lnR>
+                    <a:lnT w="6350">
+                      <a:solidFill>
+                        <a:srgbClr val="D9D9D9"/>
+                      </a:solidFill>
+                    </a:lnT>
+                    <a:lnB w="12700">
+                      <a:solidFill>
+                        <a:srgbClr val="002060"/>
+                      </a:solidFill>
+                    </a:lnB>
+                    <a:noFill/>
+                  </a:tcPr>
+                </a:tc>
+                <a:tc>
+                  <a:txBody>
+                    <a:bodyPr wrap="square"/>
+                    <a:lstStyle/>
+                    <a:p>
+                      <a:pPr algn="ctr"/>
+                      <a:r>
+                        <a:rPr sz="850" b="0">
+                          <a:solidFill>
+                            <a:srgbClr val="000000"/>
+                          </a:solidFill>
+                          <a:latin typeface="신세계 민부리 Light(TTF)"/>
+                          <a:ea typeface="신세계 민부리 Light(TTF)"/>
+                          <a:cs typeface="신세계 민부리 Light(TTF)"/>
+                        </a:rPr>
+                        <a:t>170억</a:t>
+                      </a:r>
+                    </a:p>
+                  </a:txBody>
+                  <a:tcPr marL="40000" marR="40000" marT="0" marB="0" anchor="ctr">
+                    <a:lnL w="0">
+                      <a:noFill/>
+                    </a:lnL>
+                    <a:lnR w="0">
+                      <a:noFill/>
+                    </a:lnR>
+                    <a:lnT w="6350">
+                      <a:solidFill>
+                        <a:srgbClr val="D9D9D9"/>
+                      </a:solidFill>
+                    </a:lnT>
+                    <a:lnB w="12700">
+                      <a:solidFill>
+                        <a:srgbClr val="002060"/>
+                      </a:solidFill>
+                    </a:lnB>
+                    <a:noFill/>
+                  </a:tcPr>
+                </a:tc>
+                <a:tc>
+                  <a:txBody>
+                    <a:bodyPr wrap="square"/>
+                    <a:lstStyle/>
+                    <a:p>
+                      <a:pPr algn="ctr"/>
+                      <a:r>
+                        <a:rPr sz="850" b="0">
+                          <a:solidFill>
+                            <a:srgbClr val="000000"/>
+                          </a:solidFill>
+                          <a:latin typeface="신세계 민부리 Light(TTF)"/>
+                          <a:ea typeface="신세계 민부리 Light(TTF)"/>
+                          <a:cs typeface="신세계 민부리 Light(TTF)"/>
+                        </a:rPr>
+                        <a:t>848억</a:t>
+                      </a:r>
+                    </a:p>
+                  </a:txBody>
+                  <a:tcPr marL="40000" marR="40000" marT="0" marB="0" anchor="ctr">
+                    <a:lnL w="0">
+                      <a:noFill/>
+                    </a:lnL>
+                    <a:lnR w="0">
+                      <a:noFill/>
+                    </a:lnR>
+                    <a:lnT w="6350">
+                      <a:solidFill>
+                        <a:srgbClr val="D9D9D9"/>
+                      </a:solidFill>
+                    </a:lnT>
+                    <a:lnB w="12700">
+                      <a:solidFill>
+                        <a:srgbClr val="002060"/>
+                      </a:solidFill>
+                    </a:lnB>
+                    <a:noFill/>
+                  </a:tcPr>
+                </a:tc>
+                <a:tc>
+                  <a:txBody>
+                    <a:bodyPr wrap="square"/>
+                    <a:lstStyle/>
+                    <a:p>
+                      <a:pPr algn="ctr"/>
+                      <a:r>
+                        <a:rPr sz="850" b="0">
+                          <a:solidFill>
+                            <a:srgbClr val="000000"/>
+                          </a:solidFill>
+                          <a:latin typeface="신세계 민부리 Light(TTF)"/>
+                          <a:ea typeface="신세계 민부리 Light(TTF)"/>
+                          <a:cs typeface="신세계 민부리 Light(TTF)"/>
+                        </a:rPr>
+                        <a:t>480억</a:t>
+                      </a:r>
+                    </a:p>
+                  </a:txBody>
+                  <a:tcPr marL="40000" marR="40000" marT="0" marB="0" anchor="ctr">
+                    <a:lnL w="0">
+                      <a:noFill/>
+                    </a:lnL>
+                    <a:lnR w="0">
+                      <a:noFill/>
+                    </a:lnR>
+                    <a:lnT w="6350">
+                      <a:solidFill>
+                        <a:srgbClr val="D9D9D9"/>
+                      </a:solidFill>
+                    </a:lnT>
+                    <a:lnB w="12700">
+                      <a:solidFill>
+                        <a:srgbClr val="002060"/>
+                      </a:solidFill>
+                    </a:lnB>
+                    <a:noFill/>
+                  </a:tcPr>
+                </a:tc>
+                <a:tc>
+                  <a:txBody>
+                    <a:bodyPr wrap="square"/>
+                    <a:lstStyle/>
+                    <a:p>
+                      <a:pPr algn="ctr"/>
+                      <a:r>
+                        <a:rPr sz="850" b="0">
+                          <a:solidFill>
+                            <a:srgbClr val="000000"/>
+                          </a:solidFill>
+                          <a:latin typeface="신세계 민부리 Light(TTF)"/>
+                          <a:ea typeface="신세계 민부리 Light(TTF)"/>
+                          <a:cs typeface="신세계 민부리 Light(TTF)"/>
+                        </a:rPr>
+                        <a:t>320억</a:t>
+                      </a:r>
+                    </a:p>
+                  </a:txBody>
+                  <a:tcPr marL="40000" marR="40000" marT="0" marB="0" anchor="ctr">
+                    <a:lnL w="0">
+                      <a:noFill/>
+                    </a:lnL>
+                    <a:lnR w="0">
+                      <a:noFill/>
+                    </a:lnR>
+                    <a:lnT w="6350">
+                      <a:solidFill>
+                        <a:srgbClr val="D9D9D9"/>
+                      </a:solidFill>
+                    </a:lnT>
+                    <a:lnB w="12700">
+                      <a:solidFill>
+                        <a:srgbClr val="002060"/>
+                      </a:solidFill>
+                    </a:lnB>
+                    <a:noFill/>
+                  </a:tcPr>
+                </a:tc>
+                <a:tc>
+                  <a:txBody>
+                    <a:bodyPr wrap="square"/>
+                    <a:lstStyle/>
+                    <a:p>
+                      <a:pPr algn="ctr"/>
+                      <a:r>
+                        <a:rPr sz="850" b="0">
+                          <a:solidFill>
+                            <a:srgbClr val="000000"/>
+                          </a:solidFill>
+                          <a:latin typeface="신세계 민부리 Light(TTF)"/>
+                          <a:ea typeface="신세계 민부리 Light(TTF)"/>
+                          <a:cs typeface="신세계 민부리 Light(TTF)"/>
+                        </a:rPr>
+                        <a:t>185억</a:t>
+                      </a:r>
+                    </a:p>
+                  </a:txBody>
+                  <a:tcPr marL="40000" marR="40000" marT="0" marB="0" anchor="ctr">
+                    <a:lnL w="0">
+                      <a:noFill/>
+                    </a:lnL>
+                    <a:lnR w="0">
+                      <a:noFill/>
+                    </a:lnR>
+                    <a:lnT w="6350">
+                      <a:solidFill>
+                        <a:srgbClr val="D9D9D9"/>
+                      </a:solidFill>
+                    </a:lnT>
+                    <a:lnB w="12700">
+                      <a:solidFill>
+                        <a:srgbClr val="002060"/>
+                      </a:solidFill>
+                    </a:lnB>
+                    <a:noFill/>
+                  </a:tcPr>
+                </a:tc>
+                <a:tc>
+                  <a:txBody>
+                    <a:bodyPr wrap="square"/>
+                    <a:lstStyle/>
+                    <a:p>
+                      <a:pPr algn="ctr"/>
+                      <a:r>
+                        <a:rPr sz="850" b="0">
+                          <a:solidFill>
+                            <a:srgbClr val="000000"/>
+                          </a:solidFill>
+                          <a:latin typeface="신세계 민부리 Light(TTF)"/>
+                          <a:ea typeface="신세계 민부리 Light(TTF)"/>
+                          <a:cs typeface="신세계 민부리 Light(TTF)"/>
+                        </a:rPr>
+                        <a:t>2,120억</a:t>
+                      </a:r>
+                    </a:p>
+                  </a:txBody>
+                  <a:tcPr marL="40000" marR="40000" marT="0" marB="0" anchor="ctr">
+                    <a:lnL w="0">
+                      <a:noFill/>
+                    </a:lnL>
+                    <a:lnR w="0">
+                      <a:noFill/>
+                    </a:lnR>
+                    <a:lnT w="6350">
+                      <a:solidFill>
+                        <a:srgbClr val="D9D9D9"/>
+                      </a:solidFill>
+                    </a:lnT>
+                    <a:lnB w="12700">
+                      <a:solidFill>
+                        <a:srgbClr val="002060"/>
+                      </a:solidFill>
+                    </a:lnB>
+                    <a:noFill/>
+                  </a:tcPr>
+                </a:tc>
+                <a:tc>
+                  <a:txBody>
+                    <a:bodyPr wrap="square"/>
+                    <a:lstStyle/>
+                    <a:p>
+                      <a:pPr algn="ctr"/>
+                      <a:r>
+                        <a:rPr sz="850" b="1">
+                          <a:solidFill>
+                            <a:srgbClr val="002060"/>
+                          </a:solidFill>
+                          <a:latin typeface="신세계 민부리 Bold(TTF)"/>
+                          <a:ea typeface="신세계 민부리 Bold(TTF)"/>
+                          <a:cs typeface="신세계 민부리 Bold(TTF)"/>
+                        </a:rPr>
+                        <a:t>5,810억</a:t>
+                      </a:r>
+                    </a:p>
+                  </a:txBody>
+                  <a:tcPr marL="40000" marR="40000" marT="0" marB="0" anchor="ctr">
+                    <a:lnL w="0">
+                      <a:noFill/>
+                    </a:lnL>
+                    <a:lnR w="0">
+                      <a:noFill/>
+                    </a:lnR>
+                    <a:lnT w="6350">
+                      <a:solidFill>
+                        <a:srgbClr val="D9D9D9"/>
+                      </a:solidFill>
+                    </a:lnT>
+                    <a:lnB w="12700">
+                      <a:solidFill>
+                        <a:srgbClr val="002060"/>
+                      </a:solidFill>
+                    </a:lnB>
+                    <a:solidFill>
+                      <a:srgbClr val="EAF2FB"/>
+                    </a:solidFill>
+                  </a:tcPr>
+                </a:tc>
+              </a:tr>
+            </a:tbl>
+          </a:graphicData>
+        </a:graphic>
+      </p:graphicFrame>
+      <p:sp>
+        <p:nvSpPr>
+          <p:cNvPr id="29" name="TextBox 28"/>
+          <p:cNvSpPr txBox="1"/>
+          <p:nvPr/>
+        </p:nvSpPr>
+        <p:spPr>
+          <a:xfrm>
+            <a:off x="254000" y="9000000"/>
+            <a:ext cx="6350000" cy="420000"/>
           </a:xfrm>
           <a:prstGeom prst="rect">
             <a:avLst/>
@@ -8277,6 +9088,59 @@
           <a:p>
             <a:pPr algn="l"/>
             <a:r>
+              <a:rPr sz="900" b="0">
+                <a:solidFill>
+                  <a:srgbClr val="000000"/>
+                </a:solidFill>
+                <a:latin typeface="신세계 민부리 Light(TTF)"/>
+                <a:ea typeface="신세계 민부리 Light(TTF)"/>
+                <a:cs typeface="신세계 민부리 Light(TTF)"/>
+              </a:rPr>
+              <a:t>→ 8개 중 6개 PJT가 IRR 7% 이상, 7개 PJT가 10년 내 투자회수 / 반포·광주가 연 현금흐름의 79% 창출</a:t>
+            </a:r>
+          </a:p>
+          <a:p>
+            <a:pPr algn="l">
+              <a:spcBef>
+                <a:spcPts val="200"/>
+              </a:spcBef>
+            </a:pPr>
+            <a:r>
+              <a:rPr sz="900" b="0">
+                <a:solidFill>
+                  <a:srgbClr val="000000"/>
+                </a:solidFill>
+                <a:latin typeface="신세계 민부리 Light(TTF)"/>
+                <a:ea typeface="신세계 민부리 Light(TTF)"/>
+                <a:cs typeface="신세계 민부리 Light(TTF)"/>
+              </a:rPr>
+              <a:t>→ 송도(IRR 6.6%, 회수 10년차)·센텀(IRR 4.5%)은 상대적 저수익 PJT로 수익 구조 개선 방안 검토 필요</a:t>
+            </a:r>
+          </a:p>
+        </p:txBody>
+      </p:sp>
+      <p:sp>
+        <p:nvSpPr>
+          <p:cNvPr id="30" name="TextBox 29"/>
+          <p:cNvSpPr txBox="1"/>
+          <p:nvPr/>
+        </p:nvSpPr>
+        <p:spPr>
+          <a:xfrm>
+            <a:off x="254000" y="9440000"/>
+            <a:ext cx="6350000" cy="420000"/>
+          </a:xfrm>
+          <a:prstGeom prst="rect">
+            <a:avLst/>
+          </a:prstGeom>
+          <a:noFill/>
+        </p:spPr>
+        <p:txBody>
+          <a:bodyPr wrap="square" anchor="t" lIns="0" rIns="0" tIns="0" bIns="0"/>
+          <a:lstStyle/>
+          <a:p>
+            <a:pPr algn="l"/>
+            <a:r>
               <a:rPr sz="750" b="0">
                 <a:solidFill>
                   <a:srgbClr val="595959"/>
@@ -8300,6 +9164,20 @@
                 <a:cs typeface="신세계 민부리 Light(TTF)"/>
               </a:rPr>
               <a:t>* 당사: 신세계센트럴, 百: 신세계백화점 / 사업비 단위: 조원</a:t>
+            </a:r>
+          </a:p>
+          <a:p>
+            <a:pPr algn="l"/>
+            <a:r>
+              <a:rPr sz="750" b="0">
+                <a:solidFill>
+                  <a:srgbClr val="595959"/>
+                </a:solidFill>
+                <a:latin typeface="신세계 민부리 Light(TTF)"/>
+                <a:ea typeface="신세계 민부리 Light(TTF)"/>
+                <a:cs typeface="신세계 민부리 Light(TTF)"/>
+              </a:rPr>
+              <a:t>1) 센텀: 외부투자자 IRR 14% 별도  2) 울산: 분양 기준 / 수익성 지표는 ’38년 기준</a:t>
             </a:r>
           </a:p>
         </p:txBody>

</xml_diff>

<commit_message>
Add funding need to key insight 3
Co-Authored-By: Claude Opus 5.5 <noreply@anthropic.com>
Claude-Session: https://claude.ai/code/session_01UDmzKjjdYrug7NodmfaK5P
</commit_message>
<xml_diff>
--- a/PJT_summary.pptx
+++ b/PJT_summary.pptx
@@ -3984,25 +3984,7 @@
                 <a:ea typeface="신세계 민부리 Light(TTF)"/>
                 <a:cs typeface="신세계 민부리 Light(TTF)"/>
               </a:rPr>
-              <a:t>   - ’30년 논현을 시작으로 ’34년까지 7개 PJT(12.9조) 순차 준공,</a:t>
-            </a:r>
-          </a:p>
-          <a:p>
-            <a:pPr algn="l">
-              <a:spcBef>
-                <a:spcPts val="200"/>
-              </a:spcBef>
-            </a:pPr>
-            <a:r>
-              <a:rPr sz="900" b="0">
-                <a:solidFill>
-                  <a:srgbClr val="000000"/>
-                </a:solidFill>
-                <a:latin typeface="신세계 민부리 Light(TTF)"/>
-                <a:ea typeface="신세계 민부리 Light(TTF)"/>
-                <a:cs typeface="신세계 민부리 Light(TTF)"/>
-              </a:rPr>
-              <a:t>   - ’39년 반포(19.9조) 준공으로 포트폴리오 완성</a:t>
+              <a:t>   - ’30년 논현부터 ’34년까지 7개 PJT(12.9조) 순차 준공 후, ’39년 반포(19.9조) 준공으로 완성</a:t>
             </a:r>
           </a:p>
           <a:p>
@@ -4056,7 +4038,7 @@
                 <a:ea typeface="신세계 민부리 Bold(TTF)"/>
                 <a:cs typeface="신세계 민부리 Bold(TTF)"/>
               </a:rPr>
-              <a:t>③ 반포 집중도 및 차입 부담에 대한 관리 필요</a:t>
+              <a:t>③ 총 사업비의 71%(23.3조)는 외부 조달 필요</a:t>
             </a:r>
           </a:p>
           <a:p>
@@ -4074,7 +4056,7 @@
                 <a:ea typeface="신세계 민부리 Light(TTF)"/>
                 <a:cs typeface="신세계 민부리 Light(TTF)"/>
               </a:rPr>
-              <a:t>   - 반포 1개 PJT에 당사 Equity의 95%(7.1조) 집중</a:t>
+              <a:t>   - 신세계 Equity 9.5조(29%) 외 PF·회사채 등 차입 13.8조, 분양·보증금 8.7조, 외부 Equity 0.8조 조달</a:t>
             </a:r>
           </a:p>
           <a:p>
@@ -4092,7 +4074,7 @@
                 <a:ea typeface="신세계 민부리 Light(TTF)"/>
                 <a:cs typeface="신세계 민부리 Light(TTF)"/>
               </a:rPr>
-              <a:t>   - 총 사업비의 42%(13.8조)를 PF·회사채 등 차입으로 조달 → 반포 일정 및 금리 변동 집중 관리</a:t>
+              <a:t>   - 반포에 당사 Equity의 95%(7.1조) 집중 → PJT 일정별 단계적 조달 계획 및 금리 리스크 관리 필요</a:t>
             </a:r>
           </a:p>
         </p:txBody>

</xml_diff>

<commit_message>
Replace period column with per-PJT external funding
Co-Authored-By: Claude Opus 5.5 <noreply@anthropic.com>
Claude-Session: https://claude.ai/code/session_01UDmzKjjdYrug7NodmfaK5P
</commit_message>
<xml_diff>
--- a/PJT_summary.pptx
+++ b/PJT_summary.pptx
@@ -4109,7 +4109,7 @@
                 <a:ea typeface="신세계 민부리 Bold(TTF)"/>
                 <a:cs typeface="신세계 민부리 Bold(TTF)"/>
               </a:rPr>
-              <a:t>❍  PJT별 사업비 및 예상 이익</a:t>
+              <a:t>❍  PJT별 사업비 · 조달 · 예상 이익</a:t>
             </a:r>
           </a:p>
         </p:txBody>
@@ -4135,12 +4135,12 @@
               <a:tblGrid>
                 <a:gridCol w="380000"/>
                 <a:gridCol w="520000"/>
-                <a:gridCol w="2050000"/>
-                <a:gridCol w="800000"/>
+                <a:gridCol w="1950000"/>
+                <a:gridCol w="700000"/>
                 <a:gridCol w="600000"/>
                 <a:gridCol w="900000"/>
                 <a:gridCol w="650000"/>
-                <a:gridCol w="450000"/>
+                <a:gridCol w="650000"/>
               </a:tblGrid>
               <a:tr h="250000">
                 <a:tc>
@@ -4392,7 +4392,7 @@
                           <a:ea typeface="신세계 민부리 Bold(TTF)"/>
                           <a:cs typeface="신세계 민부리 Bold(TTF)"/>
                         </a:rPr>
-                        <a:t>예상 이익</a:t>
+                        <a:t>외부 조달³⁾</a:t>
                       </a:r>
                     </a:p>
                   </a:txBody>
@@ -4431,7 +4431,7 @@
                           <a:ea typeface="신세계 민부리 Bold(TTF)"/>
                           <a:cs typeface="신세계 민부리 Bold(TTF)"/>
                         </a:rPr>
-                        <a:t>기간</a:t>
+                        <a:t>예상 이익</a:t>
                       </a:r>
                     </a:p>
                   </a:txBody>
@@ -4706,7 +4706,7 @@
                           <a:ea typeface="신세계 민부리 Light(TTF)"/>
                           <a:cs typeface="신세계 민부리 Light(TTF)"/>
                         </a:rPr>
-                        <a:t>760억</a:t>
+                        <a:t>0.53조</a:t>
                       </a:r>
                     </a:p>
                   </a:txBody>
@@ -4735,7 +4735,7 @@
                     <a:bodyPr wrap="square"/>
                     <a:lstStyle/>
                     <a:p>
-                      <a:pPr algn="ctr"/>
+                      <a:pPr algn="r"/>
                       <a:r>
                         <a:rPr sz="850" b="0">
                           <a:solidFill>
@@ -4745,7 +4745,7 @@
                           <a:ea typeface="신세계 민부리 Light(TTF)"/>
                           <a:cs typeface="신세계 민부리 Light(TTF)"/>
                         </a:rPr>
-                        <a:t>3년</a:t>
+                        <a:t>760억</a:t>
                       </a:r>
                     </a:p>
                   </a:txBody>
@@ -5020,7 +5020,7 @@
                           <a:ea typeface="신세계 민부리 Light(TTF)"/>
                           <a:cs typeface="신세계 민부리 Light(TTF)"/>
                         </a:rPr>
-                        <a:t>3,002억</a:t>
+                        <a:t>1.37조</a:t>
                       </a:r>
                     </a:p>
                   </a:txBody>
@@ -5049,7 +5049,7 @@
                     <a:bodyPr wrap="square"/>
                     <a:lstStyle/>
                     <a:p>
-                      <a:pPr algn="ctr"/>
+                      <a:pPr algn="r"/>
                       <a:r>
                         <a:rPr sz="850" b="0">
                           <a:solidFill>
@@ -5059,7 +5059,7 @@
                           <a:ea typeface="신세계 민부리 Light(TTF)"/>
                           <a:cs typeface="신세계 민부리 Light(TTF)"/>
                         </a:rPr>
-                        <a:t>12년</a:t>
+                        <a:t>3,002억</a:t>
                       </a:r>
                     </a:p>
                   </a:txBody>
@@ -5334,7 +5334,7 @@
                           <a:ea typeface="신세계 민부리 Light(TTF)"/>
                           <a:cs typeface="신세계 민부리 Light(TTF)"/>
                         </a:rPr>
-                        <a:t>2.9조</a:t>
+                        <a:t>2.15조</a:t>
                       </a:r>
                     </a:p>
                   </a:txBody>
@@ -5363,7 +5363,7 @@
                     <a:bodyPr wrap="square"/>
                     <a:lstStyle/>
                     <a:p>
-                      <a:pPr algn="ctr"/>
+                      <a:pPr algn="r"/>
                       <a:r>
                         <a:rPr sz="850" b="0">
                           <a:solidFill>
@@ -5373,7 +5373,7 @@
                           <a:ea typeface="신세계 민부리 Light(TTF)"/>
                           <a:cs typeface="신세계 민부리 Light(TTF)"/>
                         </a:rPr>
-                        <a:t>20년</a:t>
+                        <a:t>2.9조</a:t>
                       </a:r>
                     </a:p>
                   </a:txBody>
@@ -5648,7 +5648,7 @@
                           <a:ea typeface="신세계 민부리 Light(TTF)"/>
                           <a:cs typeface="신세계 민부리 Light(TTF)"/>
                         </a:rPr>
-                        <a:t>6,624억</a:t>
+                        <a:t>-</a:t>
                       </a:r>
                     </a:p>
                   </a:txBody>
@@ -5677,7 +5677,7 @@
                     <a:bodyPr wrap="square"/>
                     <a:lstStyle/>
                     <a:p>
-                      <a:pPr algn="ctr"/>
+                      <a:pPr algn="r"/>
                       <a:r>
                         <a:rPr sz="850" b="0">
                           <a:solidFill>
@@ -5687,7 +5687,7 @@
                           <a:ea typeface="신세계 민부리 Light(TTF)"/>
                           <a:cs typeface="신세계 민부리 Light(TTF)"/>
                         </a:rPr>
-                        <a:t>20년</a:t>
+                        <a:t>6,624억</a:t>
                       </a:r>
                     </a:p>
                   </a:txBody>
@@ -5962,7 +5962,7 @@
                           <a:ea typeface="신세계 민부리 Light(TTF)"/>
                           <a:cs typeface="신세계 민부리 Light(TTF)"/>
                         </a:rPr>
-                        <a:t>599억</a:t>
+                        <a:t>1.57조</a:t>
                       </a:r>
                     </a:p>
                   </a:txBody>
@@ -5991,7 +5991,7 @@
                     <a:bodyPr wrap="square"/>
                     <a:lstStyle/>
                     <a:p>
-                      <a:pPr algn="ctr"/>
+                      <a:pPr algn="r"/>
                       <a:r>
                         <a:rPr sz="850" b="0">
                           <a:solidFill>
@@ -6001,7 +6001,7 @@
                           <a:ea typeface="신세계 민부리 Light(TTF)"/>
                           <a:cs typeface="신세계 민부리 Light(TTF)"/>
                         </a:rPr>
-                        <a:t>3년</a:t>
+                        <a:t>599억</a:t>
                       </a:r>
                     </a:p>
                   </a:txBody>
@@ -6276,7 +6276,7 @@
                           <a:ea typeface="신세계 민부리 Light(TTF)"/>
                           <a:cs typeface="신세계 민부리 Light(TTF)"/>
                         </a:rPr>
-                        <a:t>1,397억</a:t>
+                        <a:t>2.58조</a:t>
                       </a:r>
                     </a:p>
                   </a:txBody>
@@ -6305,7 +6305,7 @@
                     <a:bodyPr wrap="square"/>
                     <a:lstStyle/>
                     <a:p>
-                      <a:pPr algn="ctr"/>
+                      <a:pPr algn="r"/>
                       <a:r>
                         <a:rPr sz="850" b="0">
                           <a:solidFill>
@@ -6315,7 +6315,7 @@
                           <a:ea typeface="신세계 민부리 Light(TTF)"/>
                           <a:cs typeface="신세계 민부리 Light(TTF)"/>
                         </a:rPr>
-                        <a:t>1년</a:t>
+                        <a:t>1,397억</a:t>
                       </a:r>
                     </a:p>
                   </a:txBody>
@@ -6590,7 +6590,7 @@
                           <a:ea typeface="신세계 민부리 Light(TTF)"/>
                           <a:cs typeface="신세계 민부리 Light(TTF)"/>
                         </a:rPr>
-                        <a:t>5.2조</a:t>
+                        <a:t>2.30조</a:t>
                       </a:r>
                     </a:p>
                   </a:txBody>
@@ -6619,7 +6619,7 @@
                     <a:bodyPr wrap="square"/>
                     <a:lstStyle/>
                     <a:p>
-                      <a:pPr algn="ctr"/>
+                      <a:pPr algn="r"/>
                       <a:r>
                         <a:rPr sz="850" b="0">
                           <a:solidFill>
@@ -6629,7 +6629,7 @@
                           <a:ea typeface="신세계 민부리 Light(TTF)"/>
                           <a:cs typeface="신세계 민부리 Light(TTF)"/>
                         </a:rPr>
-                        <a:t>20년</a:t>
+                        <a:t>5.2조</a:t>
                       </a:r>
                     </a:p>
                   </a:txBody>
@@ -6916,7 +6916,7 @@
                           <a:ea typeface="신세계 민부리 Bold(TTF)"/>
                           <a:cs typeface="신세계 민부리 Bold(TTF)"/>
                         </a:rPr>
-                        <a:t>27.7조</a:t>
+                        <a:t>12.77조</a:t>
                       </a:r>
                     </a:p>
                   </a:txBody>
@@ -6947,7 +6947,7 @@
                     <a:bodyPr wrap="square"/>
                     <a:lstStyle/>
                     <a:p>
-                      <a:pPr algn="ctr"/>
+                      <a:pPr algn="r"/>
                       <a:r>
                         <a:rPr sz="850" b="1">
                           <a:solidFill>
@@ -6957,7 +6957,7 @@
                           <a:ea typeface="신세계 민부리 Bold(TTF)"/>
                           <a:cs typeface="신세계 민부리 Bold(TTF)"/>
                         </a:rPr>
-                        <a:t>10년</a:t>
+                        <a:t>27.7조</a:t>
                       </a:r>
                     </a:p>
                   </a:txBody>
@@ -7246,7 +7246,7 @@
                           <a:ea typeface="신세계 민부리 Bold(TTF)"/>
                           <a:cs typeface="신세계 민부리 Bold(TTF)"/>
                         </a:rPr>
-                        <a:t>37.0조</a:t>
+                        <a:t>23.3조</a:t>
                       </a:r>
                     </a:p>
                   </a:txBody>
@@ -7277,7 +7277,7 @@
                     <a:bodyPr wrap="square"/>
                     <a:lstStyle/>
                     <a:p>
-                      <a:pPr algn="ctr"/>
+                      <a:pPr algn="r"/>
                       <a:r>
                         <a:rPr sz="850" b="1">
                           <a:solidFill>
@@ -7287,7 +7287,7 @@
                           <a:ea typeface="신세계 민부리 Bold(TTF)"/>
                           <a:cs typeface="신세계 민부리 Bold(TTF)"/>
                         </a:rPr>
-                        <a:t/>
+                        <a:t>37.0조</a:t>
                       </a:r>
                     </a:p>
                   </a:txBody>
@@ -7334,8 +7334,8 @@
         </p:blipFill>
         <p:spPr>
           <a:xfrm>
-            <a:off x="3204000" y="5080000"/>
-            <a:ext cx="800000" cy="2000000"/>
+            <a:off x="3104000" y="5080000"/>
+            <a:ext cx="700000" cy="2000000"/>
           </a:xfrm>
           <a:prstGeom prst="rect">
             <a:avLst/>
@@ -9109,8 +9109,8 @@
         </p:nvSpPr>
         <p:spPr>
           <a:xfrm>
-            <a:off x="254000" y="9440000"/>
-            <a:ext cx="6350000" cy="420000"/>
+            <a:off x="254000" y="9420000"/>
+            <a:ext cx="6350000" cy="480000"/>
           </a:xfrm>
           <a:prstGeom prst="rect">
             <a:avLst/>
@@ -9160,6 +9160,20 @@
                 <a:cs typeface="신세계 민부리 Light(TTF)"/>
               </a:rPr>
               <a:t>1) 센텀: 외부투자자 IRR 14% 별도  2) 울산: 분양 기준 / 수익성 지표는 ’38년 기준</a:t>
+            </a:r>
+          </a:p>
+          <a:p>
+            <a:pPr algn="l"/>
+            <a:r>
+              <a:rPr sz="750" b="0">
+                <a:solidFill>
+                  <a:srgbClr val="595959"/>
+                </a:solidFill>
+                <a:latin typeface="신세계 민부리 Light(TTF)"/>
+                <a:ea typeface="신세계 민부리 Light(TTF)"/>
+                <a:cs typeface="신세계 민부리 Light(TTF)"/>
+              </a:rPr>
+              <a:t>3) 외부 조달 = 사업비 − 신세계(당사·百) 투자로, 외부 Equity·PF·회사채·분양·보증금 포함</a:t>
             </a:r>
           </a:p>
         </p:txBody>

</xml_diff>